<commit_message>
docs(mathematics): create the section of the problem formulation where it shall includes all formulas its needs
</commit_message>
<xml_diff>
--- a/Thesis/07_Presentations/Master_Colloquium/First_Colloquium/Modelado de un Esquema de Aprendizaje Incremental con Memoria Distribuida en Redes Neuronales Artificiales.pptx
+++ b/Thesis/07_Presentations/Master_Colloquium/First_Colloquium/Modelado de un Esquema de Aprendizaje Incremental con Memoria Distribuida en Redes Neuronales Artificiales.pptx
@@ -5,7 +5,7 @@
     <p:sldMasterId id="2147483648" r:id="rId1"/>
   </p:sldMasterIdLst>
   <p:notesMasterIdLst>
-    <p:notesMasterId r:id="rId14"/>
+    <p:notesMasterId r:id="rId17"/>
   </p:notesMasterIdLst>
   <p:sldIdLst>
     <p:sldId id="256" r:id="rId2"/>
@@ -13,13 +13,16 @@
     <p:sldId id="259" r:id="rId4"/>
     <p:sldId id="261" r:id="rId5"/>
     <p:sldId id="262" r:id="rId6"/>
-    <p:sldId id="266" r:id="rId7"/>
-    <p:sldId id="274" r:id="rId8"/>
-    <p:sldId id="269" r:id="rId9"/>
-    <p:sldId id="270" r:id="rId10"/>
-    <p:sldId id="271" r:id="rId11"/>
-    <p:sldId id="272" r:id="rId12"/>
-    <p:sldId id="273" r:id="rId13"/>
+    <p:sldId id="275" r:id="rId7"/>
+    <p:sldId id="266" r:id="rId8"/>
+    <p:sldId id="274" r:id="rId9"/>
+    <p:sldId id="269" r:id="rId10"/>
+    <p:sldId id="277" r:id="rId11"/>
+    <p:sldId id="270" r:id="rId12"/>
+    <p:sldId id="276" r:id="rId13"/>
+    <p:sldId id="271" r:id="rId14"/>
+    <p:sldId id="272" r:id="rId15"/>
+    <p:sldId id="273" r:id="rId16"/>
   </p:sldIdLst>
   <p:sldSz cx="10080625" cy="5670550"/>
   <p:notesSz cx="7772400" cy="10058400"/>
@@ -208,7 +211,7 @@
           <a:p>
             <a:fld id="{4EBEF06D-FC33-634B-B721-76142CCAC50A}" type="datetimeFigureOut">
               <a:rPr lang="en-MX" smtClean="0"/>
-              <a:t>29/11/25</a:t>
+              <a:t>01/12/25</a:t>
             </a:fld>
             <a:endParaRPr lang="en-MX"/>
           </a:p>
@@ -4285,10 +4288,10 @@
       </p:pic>
       <p:sp>
         <p:nvSpPr>
-          <p:cNvPr id="2" name="Slide Number Placeholder 1">
+          <p:cNvPr id="3" name="Slide Number Placeholder 2">
             <a:extLst>
               <a:ext uri="{FF2B5EF4-FFF2-40B4-BE49-F238E27FC236}">
-                <a16:creationId xmlns:a16="http://schemas.microsoft.com/office/drawing/2014/main" id="{93DA5B09-9F9F-354F-48F9-C6E08C589C83}"/>
+                <a16:creationId xmlns:a16="http://schemas.microsoft.com/office/drawing/2014/main" id="{8C52A996-FD11-D820-6AC8-196C5EA4B76D}"/>
               </a:ext>
             </a:extLst>
           </p:cNvPr>
@@ -4308,7 +4311,7 @@
               <a:rPr lang="en-MX" smtClean="0"/>
               <a:t>1</a:t>
             </a:fld>
-            <a:endParaRPr lang="en-MX" dirty="0"/>
+            <a:endParaRPr lang="en-MX"/>
           </a:p>
         </p:txBody>
       </p:sp>
@@ -4321,6 +4324,1021 @@
 </file>
 
 <file path=ppt/slides/slide10.xml><?xml version="1.0" encoding="utf-8"?>
+<p:sld xmlns:a="http://schemas.openxmlformats.org/drawingml/2006/main" xmlns:r="http://schemas.openxmlformats.org/officeDocument/2006/relationships" xmlns:p="http://schemas.openxmlformats.org/presentationml/2006/main">
+  <p:cSld>
+    <p:spTree>
+      <p:nvGrpSpPr>
+        <p:cNvPr id="1" name="">
+          <a:extLst>
+            <a:ext uri="{FF2B5EF4-FFF2-40B4-BE49-F238E27FC236}">
+              <a16:creationId xmlns:a16="http://schemas.microsoft.com/office/drawing/2014/main" id="{71B6E81B-58F0-0957-5B25-57EF1DC5C1C7}"/>
+            </a:ext>
+          </a:extLst>
+        </p:cNvPr>
+        <p:cNvGrpSpPr/>
+        <p:nvPr/>
+      </p:nvGrpSpPr>
+      <p:grpSpPr>
+        <a:xfrm>
+          <a:off x="0" y="0"/>
+          <a:ext cx="0" cy="0"/>
+          <a:chOff x="0" y="0"/>
+          <a:chExt cx="0" cy="0"/>
+        </a:xfrm>
+      </p:grpSpPr>
+      <p:pic>
+        <p:nvPicPr>
+          <p:cNvPr id="117" name="Google Shape;229;p14">
+            <a:extLst>
+              <a:ext uri="{FF2B5EF4-FFF2-40B4-BE49-F238E27FC236}">
+                <a16:creationId xmlns:a16="http://schemas.microsoft.com/office/drawing/2014/main" id="{ECFE1E69-6C6A-ACF7-D941-6301C2A2C5CD}"/>
+              </a:ext>
+            </a:extLst>
+          </p:cNvPr>
+          <p:cNvPicPr/>
+          <p:nvPr/>
+        </p:nvPicPr>
+        <p:blipFill>
+          <a:blip r:embed="rId2"/>
+          <a:stretch/>
+        </p:blipFill>
+        <p:spPr>
+          <a:xfrm>
+            <a:off x="360" y="4984200"/>
+            <a:ext cx="10079280" cy="685440"/>
+          </a:xfrm>
+          <a:prstGeom prst="rect">
+            <a:avLst/>
+          </a:prstGeom>
+          <a:ln w="0">
+            <a:noFill/>
+          </a:ln>
+        </p:spPr>
+      </p:pic>
+      <p:pic>
+        <p:nvPicPr>
+          <p:cNvPr id="118" name="Google Shape;230;p14">
+            <a:extLst>
+              <a:ext uri="{FF2B5EF4-FFF2-40B4-BE49-F238E27FC236}">
+                <a16:creationId xmlns:a16="http://schemas.microsoft.com/office/drawing/2014/main" id="{E9A8E4E9-7751-19A0-7965-302F6C50D507}"/>
+              </a:ext>
+            </a:extLst>
+          </p:cNvPr>
+          <p:cNvPicPr/>
+          <p:nvPr/>
+        </p:nvPicPr>
+        <p:blipFill>
+          <a:blip r:embed="rId3"/>
+          <a:stretch/>
+        </p:blipFill>
+        <p:spPr>
+          <a:xfrm>
+            <a:off x="360" y="0"/>
+            <a:ext cx="1598400" cy="1484280"/>
+          </a:xfrm>
+          <a:prstGeom prst="rect">
+            <a:avLst/>
+          </a:prstGeom>
+          <a:ln w="0">
+            <a:noFill/>
+          </a:ln>
+        </p:spPr>
+      </p:pic>
+      <p:sp>
+        <p:nvSpPr>
+          <p:cNvPr id="2" name="AutoShape 2">
+            <a:extLst>
+              <a:ext uri="{FF2B5EF4-FFF2-40B4-BE49-F238E27FC236}">
+                <a16:creationId xmlns:a16="http://schemas.microsoft.com/office/drawing/2014/main" id="{CC159956-4A3D-1D7A-8F85-9746F62D7D0A}"/>
+              </a:ext>
+            </a:extLst>
+          </p:cNvPr>
+          <p:cNvSpPr>
+            <a:spLocks noChangeAspect="1" noChangeArrowheads="1"/>
+          </p:cNvSpPr>
+          <p:nvPr/>
+        </p:nvSpPr>
+        <p:spPr bwMode="auto">
+          <a:xfrm>
+            <a:off x="3191608" y="845893"/>
+            <a:ext cx="2475890" cy="2475890"/>
+          </a:xfrm>
+          <a:prstGeom prst="rect">
+            <a:avLst/>
+          </a:prstGeom>
+          <a:noFill/>
+          <a:extLst>
+            <a:ext uri="{909E8E84-426E-40DD-AFC4-6F175D3DCCD1}">
+              <a14:hiddenFill xmlns:a14="http://schemas.microsoft.com/office/drawing/2010/main">
+                <a:solidFill>
+                  <a:srgbClr val="FFFFFF"/>
+                </a:solidFill>
+              </a14:hiddenFill>
+            </a:ext>
+          </a:extLst>
+        </p:spPr>
+        <p:txBody>
+          <a:bodyPr vert="horz" wrap="square" lIns="91440" tIns="45720" rIns="91440" bIns="45720" numCol="1" anchor="t" anchorCtr="0" compatLnSpc="1">
+            <a:prstTxWarp prst="textNoShape">
+              <a:avLst/>
+            </a:prstTxWarp>
+          </a:bodyPr>
+          <a:lstStyle/>
+          <a:p>
+            <a:endParaRPr lang="en-MX"/>
+          </a:p>
+        </p:txBody>
+      </p:sp>
+      <p:sp>
+        <p:nvSpPr>
+          <p:cNvPr id="4" name="TextBox 3">
+            <a:extLst>
+              <a:ext uri="{FF2B5EF4-FFF2-40B4-BE49-F238E27FC236}">
+                <a16:creationId xmlns:a16="http://schemas.microsoft.com/office/drawing/2014/main" id="{3C52CFC4-B3CC-CEBC-0300-19E2532F1CDA}"/>
+              </a:ext>
+            </a:extLst>
+          </p:cNvPr>
+          <p:cNvSpPr txBox="1"/>
+          <p:nvPr/>
+        </p:nvSpPr>
+        <p:spPr>
+          <a:xfrm>
+            <a:off x="1832838" y="249697"/>
+            <a:ext cx="7925183" cy="492443"/>
+          </a:xfrm>
+          <a:prstGeom prst="rect">
+            <a:avLst/>
+          </a:prstGeom>
+          <a:noFill/>
+        </p:spPr>
+        <p:txBody>
+          <a:bodyPr wrap="none" rtlCol="0">
+            <a:spAutoFit/>
+          </a:bodyPr>
+          <a:lstStyle/>
+          <a:p>
+            <a:r>
+              <a:rPr lang="en-US" sz="2600" b="1" dirty="0" err="1">
+                <a:latin typeface="Calibri" panose="020F0502020204030204" pitchFamily="34" charset="0"/>
+                <a:cs typeface="Calibri" panose="020F0502020204030204" pitchFamily="34" charset="0"/>
+              </a:rPr>
+              <a:t>Arquitectura</a:t>
+            </a:r>
+            <a:r>
+              <a:rPr lang="en-US" sz="2600" b="1" dirty="0">
+                <a:latin typeface="Calibri" panose="020F0502020204030204" pitchFamily="34" charset="0"/>
+                <a:cs typeface="Calibri" panose="020F0502020204030204" pitchFamily="34" charset="0"/>
+              </a:rPr>
+              <a:t> de </a:t>
+            </a:r>
+            <a:r>
+              <a:rPr lang="en-US" sz="2600" b="1" dirty="0" err="1">
+                <a:latin typeface="Calibri" panose="020F0502020204030204" pitchFamily="34" charset="0"/>
+                <a:cs typeface="Calibri" panose="020F0502020204030204" pitchFamily="34" charset="0"/>
+              </a:rPr>
+              <a:t>referencia</a:t>
+            </a:r>
+            <a:r>
+              <a:rPr lang="en-US" sz="2600" b="1" dirty="0">
+                <a:latin typeface="Calibri" panose="020F0502020204030204" pitchFamily="34" charset="0"/>
+                <a:cs typeface="Calibri" panose="020F0502020204030204" pitchFamily="34" charset="0"/>
+              </a:rPr>
+              <a:t> para </a:t>
+            </a:r>
+            <a:r>
+              <a:rPr lang="en-US" sz="2600" b="1" dirty="0" err="1">
+                <a:latin typeface="Calibri" panose="020F0502020204030204" pitchFamily="34" charset="0"/>
+                <a:cs typeface="Calibri" panose="020F0502020204030204" pitchFamily="34" charset="0"/>
+              </a:rPr>
+              <a:t>el</a:t>
+            </a:r>
+            <a:r>
+              <a:rPr lang="en-US" sz="2600" b="1" dirty="0">
+                <a:latin typeface="Calibri" panose="020F0502020204030204" pitchFamily="34" charset="0"/>
+                <a:cs typeface="Calibri" panose="020F0502020204030204" pitchFamily="34" charset="0"/>
+              </a:rPr>
+              <a:t> </a:t>
+            </a:r>
+            <a:r>
+              <a:rPr lang="en-US" sz="2600" b="1" dirty="0" err="1">
+                <a:latin typeface="Calibri" panose="020F0502020204030204" pitchFamily="34" charset="0"/>
+                <a:cs typeface="Calibri" panose="020F0502020204030204" pitchFamily="34" charset="0"/>
+              </a:rPr>
+              <a:t>esquema</a:t>
+            </a:r>
+            <a:r>
+              <a:rPr lang="en-US" sz="2600" b="1" dirty="0">
+                <a:latin typeface="Calibri" panose="020F0502020204030204" pitchFamily="34" charset="0"/>
+                <a:cs typeface="Calibri" panose="020F0502020204030204" pitchFamily="34" charset="0"/>
+              </a:rPr>
+              <a:t> incremental</a:t>
+            </a:r>
+            <a:endParaRPr lang="en-MX" sz="2600" b="1" dirty="0">
+              <a:latin typeface="Calibri" panose="020F0502020204030204" pitchFamily="34" charset="0"/>
+              <a:cs typeface="Calibri" panose="020F0502020204030204" pitchFamily="34" charset="0"/>
+            </a:endParaRPr>
+          </a:p>
+        </p:txBody>
+      </p:sp>
+      <p:sp>
+        <p:nvSpPr>
+          <p:cNvPr id="6" name="AutoShape 4">
+            <a:extLst>
+              <a:ext uri="{FF2B5EF4-FFF2-40B4-BE49-F238E27FC236}">
+                <a16:creationId xmlns:a16="http://schemas.microsoft.com/office/drawing/2014/main" id="{29E1B9FC-5819-4914-45BF-0A945D39B91C}"/>
+              </a:ext>
+            </a:extLst>
+          </p:cNvPr>
+          <p:cNvSpPr>
+            <a:spLocks noChangeAspect="1" noChangeArrowheads="1"/>
+          </p:cNvSpPr>
+          <p:nvPr/>
+        </p:nvSpPr>
+        <p:spPr bwMode="auto">
+          <a:xfrm>
+            <a:off x="4887912" y="2682874"/>
+            <a:ext cx="1815037" cy="1815037"/>
+          </a:xfrm>
+          <a:prstGeom prst="rect">
+            <a:avLst/>
+          </a:prstGeom>
+          <a:noFill/>
+          <a:extLst>
+            <a:ext uri="{909E8E84-426E-40DD-AFC4-6F175D3DCCD1}">
+              <a14:hiddenFill xmlns:a14="http://schemas.microsoft.com/office/drawing/2010/main">
+                <a:solidFill>
+                  <a:srgbClr val="FFFFFF"/>
+                </a:solidFill>
+              </a14:hiddenFill>
+            </a:ext>
+          </a:extLst>
+        </p:spPr>
+        <p:txBody>
+          <a:bodyPr vert="horz" wrap="square" lIns="91440" tIns="45720" rIns="91440" bIns="45720" numCol="1" anchor="t" anchorCtr="0" compatLnSpc="1">
+            <a:prstTxWarp prst="textNoShape">
+              <a:avLst/>
+            </a:prstTxWarp>
+          </a:bodyPr>
+          <a:lstStyle/>
+          <a:p>
+            <a:endParaRPr lang="en-MX"/>
+          </a:p>
+        </p:txBody>
+      </p:sp>
+      <p:pic>
+        <p:nvPicPr>
+          <p:cNvPr id="8" name="Picture 7" descr="A diagram of a brain activity&#10;&#10;AI-generated content may be incorrect.">
+            <a:extLst>
+              <a:ext uri="{FF2B5EF4-FFF2-40B4-BE49-F238E27FC236}">
+                <a16:creationId xmlns:a16="http://schemas.microsoft.com/office/drawing/2014/main" id="{644EBC51-3F04-5800-4185-21C418F6474D}"/>
+              </a:ext>
+            </a:extLst>
+          </p:cNvPr>
+          <p:cNvPicPr>
+            <a:picLocks noChangeAspect="1"/>
+          </p:cNvPicPr>
+          <p:nvPr/>
+        </p:nvPicPr>
+        <p:blipFill>
+          <a:blip r:embed="rId4">
+            <a:extLst>
+              <a:ext uri="{28A0092B-C50C-407E-A947-70E740481C1C}">
+                <a14:useLocalDpi xmlns:a14="http://schemas.microsoft.com/office/drawing/2010/main" val="0"/>
+              </a:ext>
+            </a:extLst>
+          </a:blip>
+          <a:srcRect t="8827"/>
+          <a:stretch>
+            <a:fillRect/>
+          </a:stretch>
+        </p:blipFill>
+        <p:spPr>
+          <a:xfrm>
+            <a:off x="2807032" y="1010743"/>
+            <a:ext cx="5502082" cy="3344262"/>
+          </a:xfrm>
+          <a:prstGeom prst="rect">
+            <a:avLst/>
+          </a:prstGeom>
+        </p:spPr>
+      </p:pic>
+      <p:sp>
+        <p:nvSpPr>
+          <p:cNvPr id="9" name="Slide Number Placeholder 8">
+            <a:extLst>
+              <a:ext uri="{FF2B5EF4-FFF2-40B4-BE49-F238E27FC236}">
+                <a16:creationId xmlns:a16="http://schemas.microsoft.com/office/drawing/2014/main" id="{B25F47FB-1A67-A9D0-4B16-99DA89D04D31}"/>
+              </a:ext>
+            </a:extLst>
+          </p:cNvPr>
+          <p:cNvSpPr>
+            <a:spLocks noGrp="1"/>
+          </p:cNvSpPr>
+          <p:nvPr>
+            <p:ph type="sldNum" idx="2"/>
+          </p:nvPr>
+        </p:nvSpPr>
+        <p:spPr/>
+        <p:txBody>
+          <a:bodyPr/>
+          <a:lstStyle/>
+          <a:p>
+            <a:fld id="{B99B1A2D-D4B6-4047-AD69-D754256AF902}" type="slidenum">
+              <a:rPr lang="en-MX" smtClean="0"/>
+              <a:t>10</a:t>
+            </a:fld>
+            <a:endParaRPr lang="en-MX"/>
+          </a:p>
+        </p:txBody>
+      </p:sp>
+    </p:spTree>
+    <p:extLst>
+      <p:ext uri="{BB962C8B-B14F-4D97-AF65-F5344CB8AC3E}">
+        <p14:creationId xmlns:p14="http://schemas.microsoft.com/office/powerpoint/2010/main" val="2196736974"/>
+      </p:ext>
+    </p:extLst>
+  </p:cSld>
+  <p:clrMapOvr>
+    <a:masterClrMapping/>
+  </p:clrMapOvr>
+</p:sld>
+</file>
+
+<file path=ppt/slides/slide11.xml><?xml version="1.0" encoding="utf-8"?>
+<p:sld xmlns:a="http://schemas.openxmlformats.org/drawingml/2006/main" xmlns:r="http://schemas.openxmlformats.org/officeDocument/2006/relationships" xmlns:p="http://schemas.openxmlformats.org/presentationml/2006/main">
+  <p:cSld>
+    <p:spTree>
+      <p:nvGrpSpPr>
+        <p:cNvPr id="1" name=""/>
+        <p:cNvGrpSpPr/>
+        <p:nvPr/>
+      </p:nvGrpSpPr>
+      <p:grpSpPr>
+        <a:xfrm>
+          <a:off x="0" y="0"/>
+          <a:ext cx="0" cy="0"/>
+          <a:chOff x="0" y="0"/>
+          <a:chExt cx="0" cy="0"/>
+        </a:xfrm>
+      </p:grpSpPr>
+      <p:pic>
+        <p:nvPicPr>
+          <p:cNvPr id="121" name="Google Shape;237;p15"/>
+          <p:cNvPicPr/>
+          <p:nvPr/>
+        </p:nvPicPr>
+        <p:blipFill>
+          <a:blip r:embed="rId2"/>
+          <a:stretch/>
+        </p:blipFill>
+        <p:spPr>
+          <a:xfrm>
+            <a:off x="360" y="4984200"/>
+            <a:ext cx="10079280" cy="685440"/>
+          </a:xfrm>
+          <a:prstGeom prst="rect">
+            <a:avLst/>
+          </a:prstGeom>
+          <a:ln w="0">
+            <a:noFill/>
+          </a:ln>
+        </p:spPr>
+      </p:pic>
+      <p:pic>
+        <p:nvPicPr>
+          <p:cNvPr id="122" name="Google Shape;238;p15"/>
+          <p:cNvPicPr/>
+          <p:nvPr/>
+        </p:nvPicPr>
+        <p:blipFill>
+          <a:blip r:embed="rId3"/>
+          <a:stretch/>
+        </p:blipFill>
+        <p:spPr>
+          <a:xfrm>
+            <a:off x="360" y="0"/>
+            <a:ext cx="1598400" cy="1484280"/>
+          </a:xfrm>
+          <a:prstGeom prst="rect">
+            <a:avLst/>
+          </a:prstGeom>
+          <a:ln w="0">
+            <a:noFill/>
+          </a:ln>
+        </p:spPr>
+      </p:pic>
+      <p:sp>
+        <p:nvSpPr>
+          <p:cNvPr id="123" name="Google Shape;239;p15"/>
+          <p:cNvSpPr/>
+          <p:nvPr/>
+        </p:nvSpPr>
+        <p:spPr>
+          <a:xfrm>
+            <a:off x="922320" y="1915200"/>
+            <a:ext cx="8565480" cy="2677656"/>
+          </a:xfrm>
+          <a:prstGeom prst="rect">
+            <a:avLst/>
+          </a:prstGeom>
+          <a:noFill/>
+          <a:ln w="0">
+            <a:noFill/>
+          </a:ln>
+        </p:spPr>
+        <p:style>
+          <a:lnRef idx="0">
+            <a:scrgbClr r="0" g="0" b="0"/>
+          </a:lnRef>
+          <a:fillRef idx="0">
+            <a:scrgbClr r="0" g="0" b="0"/>
+          </a:fillRef>
+          <a:effectRef idx="0">
+            <a:scrgbClr r="0" g="0" b="0"/>
+          </a:effectRef>
+          <a:fontRef idx="minor"/>
+        </p:style>
+        <p:txBody>
+          <a:bodyPr anchor="t">
+            <a:spAutoFit/>
+          </a:bodyPr>
+          <a:lstStyle/>
+          <a:p>
+            <a:pPr marL="285840" indent="-285840" algn="just">
+              <a:lnSpc>
+                <a:spcPct val="100000"/>
+              </a:lnSpc>
+              <a:buClr>
+                <a:srgbClr val="000000"/>
+              </a:buClr>
+              <a:buFont typeface="Arial"/>
+              <a:buChar char="•"/>
+            </a:pPr>
+            <a:r>
+              <a:rPr lang="es-ES" sz="2400" b="0" strike="noStrike" spc="-1" dirty="0">
+                <a:solidFill>
+                  <a:srgbClr val="000000"/>
+                </a:solidFill>
+                <a:latin typeface="Calibri"/>
+                <a:ea typeface="Calibri"/>
+              </a:rPr>
+              <a:t>Recrear el código de </a:t>
+            </a:r>
+            <a:r>
+              <a:rPr lang="es-ES" sz="2400" b="0" strike="noStrike" spc="-1" dirty="0" err="1">
+                <a:solidFill>
+                  <a:srgbClr val="000000"/>
+                </a:solidFill>
+                <a:latin typeface="Calibri"/>
+                <a:ea typeface="Calibri"/>
+              </a:rPr>
+              <a:t>Bullinaria</a:t>
+            </a:r>
+            <a:r>
+              <a:rPr lang="es-ES" sz="2400" b="0" strike="noStrike" spc="-1" dirty="0">
+                <a:solidFill>
+                  <a:srgbClr val="000000"/>
+                </a:solidFill>
+                <a:latin typeface="Calibri"/>
+                <a:ea typeface="Calibri"/>
+              </a:rPr>
+              <a:t> en Python</a:t>
+            </a:r>
+            <a:endParaRPr lang="es-MX" sz="2400" b="0" strike="noStrike" spc="-1" dirty="0">
+              <a:latin typeface="Arial"/>
+            </a:endParaRPr>
+          </a:p>
+          <a:p>
+            <a:pPr algn="just">
+              <a:lnSpc>
+                <a:spcPct val="100000"/>
+              </a:lnSpc>
+              <a:buNone/>
+              <a:tabLst>
+                <a:tab pos="0" algn="l"/>
+              </a:tabLst>
+            </a:pPr>
+            <a:endParaRPr lang="es-MX" sz="2400" b="0" strike="noStrike" spc="-1" dirty="0">
+              <a:latin typeface="Arial"/>
+            </a:endParaRPr>
+          </a:p>
+          <a:p>
+            <a:pPr marL="285840" indent="-285840" algn="just">
+              <a:lnSpc>
+                <a:spcPct val="100000"/>
+              </a:lnSpc>
+              <a:buClr>
+                <a:srgbClr val="000000"/>
+              </a:buClr>
+              <a:buFont typeface="Arial"/>
+              <a:buChar char="•"/>
+              <a:tabLst>
+                <a:tab pos="0" algn="l"/>
+              </a:tabLst>
+            </a:pPr>
+            <a:r>
+              <a:rPr lang="es-ES" sz="2400" b="0" strike="noStrike" spc="-1" dirty="0">
+                <a:solidFill>
+                  <a:srgbClr val="000000"/>
+                </a:solidFill>
+                <a:latin typeface="Calibri"/>
+                <a:ea typeface="Calibri"/>
+              </a:rPr>
+              <a:t>Extender el código con mas de dos matrices de pesos duplicados</a:t>
+            </a:r>
+            <a:endParaRPr lang="es-MX" sz="2400" b="0" strike="noStrike" spc="-1" dirty="0">
+              <a:latin typeface="Arial"/>
+            </a:endParaRPr>
+          </a:p>
+          <a:p>
+            <a:pPr>
+              <a:lnSpc>
+                <a:spcPct val="100000"/>
+              </a:lnSpc>
+              <a:buNone/>
+              <a:tabLst>
+                <a:tab pos="0" algn="l"/>
+              </a:tabLst>
+            </a:pPr>
+            <a:endParaRPr lang="es-MX" sz="2400" b="0" strike="noStrike" spc="-1" dirty="0">
+              <a:latin typeface="Arial"/>
+            </a:endParaRPr>
+          </a:p>
+          <a:p>
+            <a:pPr marL="285840" indent="-285840">
+              <a:lnSpc>
+                <a:spcPct val="100000"/>
+              </a:lnSpc>
+              <a:buClr>
+                <a:srgbClr val="000000"/>
+              </a:buClr>
+              <a:buFont typeface="Arial"/>
+              <a:buChar char="•"/>
+              <a:tabLst>
+                <a:tab pos="0" algn="l"/>
+              </a:tabLst>
+            </a:pPr>
+            <a:r>
+              <a:rPr lang="es-ES" sz="2400" b="0" strike="noStrike" spc="-1" dirty="0">
+                <a:solidFill>
+                  <a:srgbClr val="000000"/>
+                </a:solidFill>
+                <a:latin typeface="Calibri"/>
+                <a:ea typeface="Calibri"/>
+              </a:rPr>
+              <a:t>Realizar una comparación de ambos resultados</a:t>
+            </a:r>
+          </a:p>
+          <a:p>
+            <a:pPr marL="285840" indent="-285840">
+              <a:lnSpc>
+                <a:spcPct val="100000"/>
+              </a:lnSpc>
+              <a:buClr>
+                <a:srgbClr val="000000"/>
+              </a:buClr>
+              <a:buFont typeface="Arial"/>
+              <a:buChar char="•"/>
+              <a:tabLst>
+                <a:tab pos="0" algn="l"/>
+              </a:tabLst>
+            </a:pPr>
+            <a:endParaRPr lang="es-ES" sz="2400" spc="-1" dirty="0">
+              <a:solidFill>
+                <a:srgbClr val="000000"/>
+              </a:solidFill>
+              <a:latin typeface="Calibri"/>
+            </a:endParaRPr>
+          </a:p>
+          <a:p>
+            <a:pPr marL="285840" indent="-285840">
+              <a:lnSpc>
+                <a:spcPct val="100000"/>
+              </a:lnSpc>
+              <a:buClr>
+                <a:srgbClr val="000000"/>
+              </a:buClr>
+              <a:buFont typeface="Arial"/>
+              <a:buChar char="•"/>
+              <a:tabLst>
+                <a:tab pos="0" algn="l"/>
+              </a:tabLst>
+            </a:pPr>
+            <a:r>
+              <a:rPr lang="es-ES" sz="2400" b="0" strike="noStrike" spc="-1" dirty="0">
+                <a:solidFill>
+                  <a:srgbClr val="000000"/>
+                </a:solidFill>
+                <a:latin typeface="Calibri"/>
+              </a:rPr>
+              <a:t>Realizar pruebas con 6 </a:t>
+            </a:r>
+            <a:r>
+              <a:rPr lang="es-ES" sz="2400" b="0" strike="noStrike" spc="-1" dirty="0" err="1">
+                <a:solidFill>
+                  <a:srgbClr val="000000"/>
+                </a:solidFill>
+                <a:latin typeface="Calibri"/>
+              </a:rPr>
+              <a:t>datasets</a:t>
+            </a:r>
+            <a:r>
+              <a:rPr lang="es-ES" sz="2400" b="0" strike="noStrike" spc="-1" dirty="0">
+                <a:solidFill>
+                  <a:srgbClr val="000000"/>
+                </a:solidFill>
+                <a:latin typeface="Calibri"/>
+              </a:rPr>
+              <a:t> distintos</a:t>
+            </a:r>
+            <a:endParaRPr lang="es-MX" sz="2400" b="0" strike="noStrike" spc="-1" dirty="0">
+              <a:latin typeface="Arial"/>
+            </a:endParaRPr>
+          </a:p>
+        </p:txBody>
+      </p:sp>
+      <p:sp>
+        <p:nvSpPr>
+          <p:cNvPr id="124" name="Google Shape;240;p15"/>
+          <p:cNvSpPr/>
+          <p:nvPr/>
+        </p:nvSpPr>
+        <p:spPr>
+          <a:xfrm>
+            <a:off x="4031280" y="398160"/>
+            <a:ext cx="2971440" cy="607320"/>
+          </a:xfrm>
+          <a:prstGeom prst="rect">
+            <a:avLst/>
+          </a:prstGeom>
+          <a:noFill/>
+          <a:ln w="0">
+            <a:noFill/>
+          </a:ln>
+        </p:spPr>
+        <p:style>
+          <a:lnRef idx="0">
+            <a:scrgbClr r="0" g="0" b="0"/>
+          </a:lnRef>
+          <a:fillRef idx="0">
+            <a:scrgbClr r="0" g="0" b="0"/>
+          </a:fillRef>
+          <a:effectRef idx="0">
+            <a:scrgbClr r="0" g="0" b="0"/>
+          </a:effectRef>
+          <a:fontRef idx="minor"/>
+        </p:style>
+        <p:txBody>
+          <a:bodyPr anchor="ctr">
+            <a:normAutofit/>
+          </a:bodyPr>
+          <a:lstStyle/>
+          <a:p>
+            <a:pPr algn="ctr">
+              <a:lnSpc>
+                <a:spcPct val="100000"/>
+              </a:lnSpc>
+              <a:buNone/>
+              <a:tabLst>
+                <a:tab pos="0" algn="l"/>
+              </a:tabLst>
+            </a:pPr>
+            <a:r>
+              <a:rPr lang="es-ES" sz="2600" b="1" strike="noStrike" spc="-1" dirty="0">
+                <a:solidFill>
+                  <a:srgbClr val="000000"/>
+                </a:solidFill>
+                <a:latin typeface="Calibri"/>
+                <a:ea typeface="Calibri"/>
+              </a:rPr>
+              <a:t>Metodología </a:t>
+            </a:r>
+            <a:endParaRPr lang="es-MX" sz="2600" b="0" strike="noStrike" spc="-1" dirty="0">
+              <a:latin typeface="Arial"/>
+            </a:endParaRPr>
+          </a:p>
+        </p:txBody>
+      </p:sp>
+      <p:sp>
+        <p:nvSpPr>
+          <p:cNvPr id="2" name="Slide Number Placeholder 1">
+            <a:extLst>
+              <a:ext uri="{FF2B5EF4-FFF2-40B4-BE49-F238E27FC236}">
+                <a16:creationId xmlns:a16="http://schemas.microsoft.com/office/drawing/2014/main" id="{CCF0AC78-5E2E-ABDC-4DBB-580D4ED5C65F}"/>
+              </a:ext>
+            </a:extLst>
+          </p:cNvPr>
+          <p:cNvSpPr>
+            <a:spLocks noGrp="1"/>
+          </p:cNvSpPr>
+          <p:nvPr>
+            <p:ph type="sldNum" idx="2"/>
+          </p:nvPr>
+        </p:nvSpPr>
+        <p:spPr/>
+        <p:txBody>
+          <a:bodyPr/>
+          <a:lstStyle/>
+          <a:p>
+            <a:fld id="{B99B1A2D-D4B6-4047-AD69-D754256AF902}" type="slidenum">
+              <a:rPr lang="en-MX" smtClean="0"/>
+              <a:t>11</a:t>
+            </a:fld>
+            <a:endParaRPr lang="en-MX"/>
+          </a:p>
+        </p:txBody>
+      </p:sp>
+    </p:spTree>
+  </p:cSld>
+  <p:clrMapOvr>
+    <a:masterClrMapping/>
+  </p:clrMapOvr>
+</p:sld>
+</file>
+
+<file path=ppt/slides/slide12.xml><?xml version="1.0" encoding="utf-8"?>
+<p:sld xmlns:a="http://schemas.openxmlformats.org/drawingml/2006/main" xmlns:r="http://schemas.openxmlformats.org/officeDocument/2006/relationships" xmlns:p="http://schemas.openxmlformats.org/presentationml/2006/main">
+  <p:cSld>
+    <p:spTree>
+      <p:nvGrpSpPr>
+        <p:cNvPr id="1" name="">
+          <a:extLst>
+            <a:ext uri="{FF2B5EF4-FFF2-40B4-BE49-F238E27FC236}">
+              <a16:creationId xmlns:a16="http://schemas.microsoft.com/office/drawing/2014/main" id="{4B5D4803-8E37-6B7C-B62A-5A2051DC797F}"/>
+            </a:ext>
+          </a:extLst>
+        </p:cNvPr>
+        <p:cNvGrpSpPr/>
+        <p:nvPr/>
+      </p:nvGrpSpPr>
+      <p:grpSpPr>
+        <a:xfrm>
+          <a:off x="0" y="0"/>
+          <a:ext cx="0" cy="0"/>
+          <a:chOff x="0" y="0"/>
+          <a:chExt cx="0" cy="0"/>
+        </a:xfrm>
+      </p:grpSpPr>
+      <p:pic>
+        <p:nvPicPr>
+          <p:cNvPr id="121" name="Google Shape;237;p15">
+            <a:extLst>
+              <a:ext uri="{FF2B5EF4-FFF2-40B4-BE49-F238E27FC236}">
+                <a16:creationId xmlns:a16="http://schemas.microsoft.com/office/drawing/2014/main" id="{2BAF655F-7418-4D46-6C0C-FC115DA28826}"/>
+              </a:ext>
+            </a:extLst>
+          </p:cNvPr>
+          <p:cNvPicPr/>
+          <p:nvPr/>
+        </p:nvPicPr>
+        <p:blipFill>
+          <a:blip r:embed="rId2"/>
+          <a:stretch/>
+        </p:blipFill>
+        <p:spPr>
+          <a:xfrm>
+            <a:off x="360" y="4984200"/>
+            <a:ext cx="10079280" cy="685440"/>
+          </a:xfrm>
+          <a:prstGeom prst="rect">
+            <a:avLst/>
+          </a:prstGeom>
+          <a:ln w="0">
+            <a:noFill/>
+          </a:ln>
+        </p:spPr>
+      </p:pic>
+      <p:pic>
+        <p:nvPicPr>
+          <p:cNvPr id="122" name="Google Shape;238;p15">
+            <a:extLst>
+              <a:ext uri="{FF2B5EF4-FFF2-40B4-BE49-F238E27FC236}">
+                <a16:creationId xmlns:a16="http://schemas.microsoft.com/office/drawing/2014/main" id="{2D5EA10E-E4A4-F423-01A8-8E8748AB9A14}"/>
+              </a:ext>
+            </a:extLst>
+          </p:cNvPr>
+          <p:cNvPicPr/>
+          <p:nvPr/>
+        </p:nvPicPr>
+        <p:blipFill>
+          <a:blip r:embed="rId3"/>
+          <a:stretch/>
+        </p:blipFill>
+        <p:spPr>
+          <a:xfrm>
+            <a:off x="360" y="0"/>
+            <a:ext cx="1598400" cy="1484280"/>
+          </a:xfrm>
+          <a:prstGeom prst="rect">
+            <a:avLst/>
+          </a:prstGeom>
+          <a:ln w="0">
+            <a:noFill/>
+          </a:ln>
+        </p:spPr>
+      </p:pic>
+      <p:sp>
+        <p:nvSpPr>
+          <p:cNvPr id="124" name="Google Shape;240;p15">
+            <a:extLst>
+              <a:ext uri="{FF2B5EF4-FFF2-40B4-BE49-F238E27FC236}">
+                <a16:creationId xmlns:a16="http://schemas.microsoft.com/office/drawing/2014/main" id="{FAB84CF1-DE95-7314-637B-678D96398D1C}"/>
+              </a:ext>
+            </a:extLst>
+          </p:cNvPr>
+          <p:cNvSpPr/>
+          <p:nvPr/>
+        </p:nvSpPr>
+        <p:spPr>
+          <a:xfrm>
+            <a:off x="1367624" y="448435"/>
+            <a:ext cx="7839986" cy="428776"/>
+          </a:xfrm>
+          <a:prstGeom prst="rect">
+            <a:avLst/>
+          </a:prstGeom>
+          <a:noFill/>
+          <a:ln w="0">
+            <a:noFill/>
+          </a:ln>
+        </p:spPr>
+        <p:style>
+          <a:lnRef idx="0">
+            <a:scrgbClr r="0" g="0" b="0"/>
+          </a:lnRef>
+          <a:fillRef idx="0">
+            <a:scrgbClr r="0" g="0" b="0"/>
+          </a:fillRef>
+          <a:effectRef idx="0">
+            <a:scrgbClr r="0" g="0" b="0"/>
+          </a:effectRef>
+          <a:fontRef idx="minor"/>
+        </p:style>
+        <p:txBody>
+          <a:bodyPr anchor="ctr">
+            <a:noAutofit/>
+          </a:bodyPr>
+          <a:lstStyle/>
+          <a:p>
+            <a:pPr algn="ctr">
+              <a:lnSpc>
+                <a:spcPct val="100000"/>
+              </a:lnSpc>
+              <a:buNone/>
+              <a:tabLst>
+                <a:tab pos="0" algn="l"/>
+              </a:tabLst>
+            </a:pPr>
+            <a:r>
+              <a:rPr lang="en-US" sz="2600" b="1" dirty="0" err="1">
+                <a:latin typeface="Calibri" panose="020F0502020204030204" pitchFamily="34" charset="0"/>
+                <a:cs typeface="Calibri" panose="020F0502020204030204" pitchFamily="34" charset="0"/>
+              </a:rPr>
+              <a:t>Resultados</a:t>
+            </a:r>
+            <a:r>
+              <a:rPr lang="en-US" sz="2600" b="1" dirty="0">
+                <a:latin typeface="Calibri" panose="020F0502020204030204" pitchFamily="34" charset="0"/>
+                <a:cs typeface="Calibri" panose="020F0502020204030204" pitchFamily="34" charset="0"/>
+              </a:rPr>
+              <a:t> de la </a:t>
+            </a:r>
+            <a:r>
+              <a:rPr lang="en-US" sz="2600" b="1" dirty="0" err="1">
+                <a:latin typeface="Calibri" panose="020F0502020204030204" pitchFamily="34" charset="0"/>
+                <a:cs typeface="Calibri" panose="020F0502020204030204" pitchFamily="34" charset="0"/>
+              </a:rPr>
+              <a:t>Réplica</a:t>
+            </a:r>
+            <a:r>
+              <a:rPr lang="en-US" sz="2600" b="1" dirty="0">
+                <a:latin typeface="Calibri" panose="020F0502020204030204" pitchFamily="34" charset="0"/>
+                <a:cs typeface="Calibri" panose="020F0502020204030204" pitchFamily="34" charset="0"/>
+              </a:rPr>
+              <a:t> del Modelo de </a:t>
+            </a:r>
+            <a:r>
+              <a:rPr lang="en-US" sz="2600" b="1" dirty="0" err="1">
+                <a:latin typeface="Calibri" panose="020F0502020204030204" pitchFamily="34" charset="0"/>
+                <a:cs typeface="Calibri" panose="020F0502020204030204" pitchFamily="34" charset="0"/>
+              </a:rPr>
+              <a:t>Bullinaria</a:t>
+            </a:r>
+            <a:r>
+              <a:rPr lang="en-US" sz="2600" b="1" dirty="0">
+                <a:latin typeface="Calibri" panose="020F0502020204030204" pitchFamily="34" charset="0"/>
+                <a:cs typeface="Calibri" panose="020F0502020204030204" pitchFamily="34" charset="0"/>
+              </a:rPr>
+              <a:t> </a:t>
+            </a:r>
+            <a:r>
+              <a:rPr lang="en-US" sz="2600" b="1" dirty="0" err="1">
+                <a:latin typeface="Calibri" panose="020F0502020204030204" pitchFamily="34" charset="0"/>
+                <a:cs typeface="Calibri" panose="020F0502020204030204" pitchFamily="34" charset="0"/>
+              </a:rPr>
+              <a:t>en</a:t>
+            </a:r>
+            <a:r>
+              <a:rPr lang="en-US" sz="2600" b="1" dirty="0">
+                <a:latin typeface="Calibri" panose="020F0502020204030204" pitchFamily="34" charset="0"/>
+                <a:cs typeface="Calibri" panose="020F0502020204030204" pitchFamily="34" charset="0"/>
+              </a:rPr>
+              <a:t> </a:t>
+            </a:r>
+            <a:r>
+              <a:rPr lang="en-US" sz="2600" b="1" dirty="0" err="1">
+                <a:latin typeface="Calibri" panose="020F0502020204030204" pitchFamily="34" charset="0"/>
+                <a:cs typeface="Calibri" panose="020F0502020204030204" pitchFamily="34" charset="0"/>
+              </a:rPr>
+              <a:t>PyTorch</a:t>
+            </a:r>
+            <a:endParaRPr lang="es-MX" sz="2600" b="1" strike="noStrike" spc="-1" dirty="0">
+              <a:latin typeface="Calibri" panose="020F0502020204030204" pitchFamily="34" charset="0"/>
+              <a:cs typeface="Calibri" panose="020F0502020204030204" pitchFamily="34" charset="0"/>
+            </a:endParaRPr>
+          </a:p>
+        </p:txBody>
+      </p:sp>
+      <p:pic>
+        <p:nvPicPr>
+          <p:cNvPr id="2" name="Picture 1" descr="A screenshot of a computer&#10;&#10;AI-generated content may be incorrect.">
+            <a:extLst>
+              <a:ext uri="{FF2B5EF4-FFF2-40B4-BE49-F238E27FC236}">
+                <a16:creationId xmlns:a16="http://schemas.microsoft.com/office/drawing/2014/main" id="{5A023411-19F3-07A4-CB18-C4EA25FC0D7C}"/>
+              </a:ext>
+            </a:extLst>
+          </p:cNvPr>
+          <p:cNvPicPr>
+            <a:picLocks noChangeAspect="1"/>
+          </p:cNvPicPr>
+          <p:nvPr/>
+        </p:nvPicPr>
+        <p:blipFill>
+          <a:blip r:embed="rId4">
+            <a:extLst>
+              <a:ext uri="{28A0092B-C50C-407E-A947-70E740481C1C}">
+                <a14:useLocalDpi xmlns:a14="http://schemas.microsoft.com/office/drawing/2010/main" val="0"/>
+              </a:ext>
+            </a:extLst>
+          </a:blip>
+          <a:srcRect l="11705" t="5726" r="2093" b="39698"/>
+          <a:stretch>
+            <a:fillRect/>
+          </a:stretch>
+        </p:blipFill>
+        <p:spPr>
+          <a:xfrm>
+            <a:off x="2120163" y="1310604"/>
+            <a:ext cx="6390761" cy="2806810"/>
+          </a:xfrm>
+          <a:prstGeom prst="rect">
+            <a:avLst/>
+          </a:prstGeom>
+        </p:spPr>
+      </p:pic>
+      <p:sp>
+        <p:nvSpPr>
+          <p:cNvPr id="3" name="Slide Number Placeholder 2">
+            <a:extLst>
+              <a:ext uri="{FF2B5EF4-FFF2-40B4-BE49-F238E27FC236}">
+                <a16:creationId xmlns:a16="http://schemas.microsoft.com/office/drawing/2014/main" id="{5D0D4205-2AF3-447A-E036-8752246DA840}"/>
+              </a:ext>
+            </a:extLst>
+          </p:cNvPr>
+          <p:cNvSpPr>
+            <a:spLocks noGrp="1"/>
+          </p:cNvSpPr>
+          <p:nvPr>
+            <p:ph type="sldNum" idx="2"/>
+          </p:nvPr>
+        </p:nvSpPr>
+        <p:spPr/>
+        <p:txBody>
+          <a:bodyPr/>
+          <a:lstStyle/>
+          <a:p>
+            <a:fld id="{B99B1A2D-D4B6-4047-AD69-D754256AF902}" type="slidenum">
+              <a:rPr lang="en-MX" smtClean="0"/>
+              <a:t>12</a:t>
+            </a:fld>
+            <a:endParaRPr lang="en-MX"/>
+          </a:p>
+        </p:txBody>
+      </p:sp>
+    </p:spTree>
+    <p:extLst>
+      <p:ext uri="{BB962C8B-B14F-4D97-AF65-F5344CB8AC3E}">
+        <p14:creationId xmlns:p14="http://schemas.microsoft.com/office/powerpoint/2010/main" val="3667941804"/>
+      </p:ext>
+    </p:extLst>
+  </p:cSld>
+  <p:clrMapOvr>
+    <a:masterClrMapping/>
+  </p:clrMapOvr>
+</p:sld>
+</file>
+
+<file path=ppt/slides/slide13.xml><?xml version="1.0" encoding="utf-8"?>
 <p:sld xmlns:a="http://schemas.openxmlformats.org/drawingml/2006/main" xmlns:r="http://schemas.openxmlformats.org/officeDocument/2006/relationships" xmlns:p="http://schemas.openxmlformats.org/presentationml/2006/main">
   <p:cSld>
     <p:spTree>
@@ -4416,7 +5434,7 @@
         </p:style>
         <p:txBody>
           <a:bodyPr anchor="ctr">
-            <a:normAutofit fontScale="92500" lnSpcReduction="20000"/>
+            <a:noAutofit/>
           </a:bodyPr>
           <a:lstStyle/>
           <a:p>
@@ -4434,13 +5452,15 @@
                 <a:solidFill>
                   <a:srgbClr val="000000"/>
                 </a:solidFill>
-                <a:latin typeface="Calibri"/>
+                <a:latin typeface="Calibri" panose="020F0502020204030204" pitchFamily="34" charset="0"/>
                 <a:ea typeface="Calibri"/>
+                <a:cs typeface="Calibri" panose="020F0502020204030204" pitchFamily="34" charset="0"/>
               </a:rPr>
               <a:t>Cronograma de </a:t>
             </a:r>
             <a:endParaRPr lang="es-MX" sz="2600" b="0" strike="noStrike" spc="-1" dirty="0">
-              <a:latin typeface="Arial"/>
+              <a:latin typeface="Calibri" panose="020F0502020204030204" pitchFamily="34" charset="0"/>
+              <a:cs typeface="Calibri" panose="020F0502020204030204" pitchFamily="34" charset="0"/>
             </a:endParaRPr>
           </a:p>
           <a:p>
@@ -4458,104 +5478,25 @@
                 <a:solidFill>
                   <a:srgbClr val="000000"/>
                 </a:solidFill>
-                <a:latin typeface="Calibri"/>
+                <a:latin typeface="Calibri" panose="020F0502020204030204" pitchFamily="34" charset="0"/>
                 <a:ea typeface="Calibri"/>
+                <a:cs typeface="Calibri" panose="020F0502020204030204" pitchFamily="34" charset="0"/>
               </a:rPr>
               <a:t>Actividades </a:t>
             </a:r>
             <a:endParaRPr lang="es-MX" sz="2600" b="0" strike="noStrike" spc="-1" dirty="0">
-              <a:latin typeface="Arial"/>
-            </a:endParaRPr>
-          </a:p>
-        </p:txBody>
-      </p:sp>
-      <p:sp>
-        <p:nvSpPr>
-          <p:cNvPr id="129" name="PlaceHolder 1"/>
-          <p:cNvSpPr>
-            <a:spLocks noGrp="1"/>
-          </p:cNvSpPr>
-          <p:nvPr>
-            <p:ph type="sldNum" idx="18"/>
-          </p:nvPr>
-        </p:nvSpPr>
-        <p:spPr>
-          <a:xfrm>
-            <a:off x="7227360" y="5165280"/>
-            <a:ext cx="2347920" cy="390240"/>
-          </a:xfrm>
-          <a:prstGeom prst="rect">
-            <a:avLst/>
-          </a:prstGeom>
-          <a:noFill/>
-          <a:ln w="0">
-            <a:noFill/>
-          </a:ln>
-        </p:spPr>
-        <p:txBody>
-          <a:bodyPr lIns="0" tIns="0" rIns="0" bIns="0" anchor="t">
-            <a:noAutofit/>
-          </a:bodyPr>
-          <a:lstStyle>
-            <a:lvl1pPr algn="r">
-              <a:lnSpc>
-                <a:spcPct val="100000"/>
-              </a:lnSpc>
-              <a:buNone/>
-              <a:tabLst>
-                <a:tab pos="0" algn="l"/>
-              </a:tabLst>
-              <a:defRPr lang="es-ES" sz="1400" b="0" strike="noStrike" spc="-1">
-                <a:solidFill>
-                  <a:srgbClr val="000000"/>
-                </a:solidFill>
-                <a:latin typeface="Times New Roman"/>
-                <a:ea typeface="Times New Roman"/>
-              </a:defRPr>
-            </a:lvl1pPr>
-          </a:lstStyle>
-          <a:p>
-            <a:pPr algn="r">
-              <a:lnSpc>
-                <a:spcPct val="100000"/>
-              </a:lnSpc>
-              <a:buNone/>
-              <a:tabLst>
-                <a:tab pos="0" algn="l"/>
-              </a:tabLst>
-            </a:pPr>
-            <a:fld id="{6D6A1D08-52D5-4D10-BA1E-CF311FF8B82C}" type="slidenum">
-              <a:rPr lang="es-ES" sz="1400" b="0" strike="noStrike" spc="-1" smtClean="0">
-                <a:solidFill>
-                  <a:srgbClr val="000000"/>
-                </a:solidFill>
-                <a:latin typeface="Times New Roman"/>
-                <a:ea typeface="Times New Roman"/>
-              </a:rPr>
-              <a:t>10</a:t>
-            </a:fld>
-            <a:r>
-              <a:rPr lang="es-ES" sz="1400" b="0" strike="noStrike" spc="-1" dirty="0">
-                <a:solidFill>
-                  <a:srgbClr val="000000"/>
-                </a:solidFill>
-                <a:latin typeface="Times New Roman"/>
-                <a:ea typeface="Times New Roman"/>
-              </a:rPr>
-              <a:t>/16</a:t>
-            </a:r>
-            <a:endParaRPr lang="es-MX" sz="1400" b="0" strike="noStrike" spc="-1" dirty="0">
-              <a:latin typeface="Times New Roman"/>
+              <a:latin typeface="Calibri" panose="020F0502020204030204" pitchFamily="34" charset="0"/>
+              <a:cs typeface="Calibri" panose="020F0502020204030204" pitchFamily="34" charset="0"/>
             </a:endParaRPr>
           </a:p>
         </p:txBody>
       </p:sp>
       <p:pic>
         <p:nvPicPr>
-          <p:cNvPr id="2" name="Picture 1">
+          <p:cNvPr id="4" name="Picture 3">
             <a:extLst>
               <a:ext uri="{FF2B5EF4-FFF2-40B4-BE49-F238E27FC236}">
-                <a16:creationId xmlns:a16="http://schemas.microsoft.com/office/drawing/2014/main" id="{F34CEE0A-A551-55ED-89D4-6F0BA679EDE4}"/>
+                <a16:creationId xmlns:a16="http://schemas.microsoft.com/office/drawing/2014/main" id="{F67A9265-BA00-982D-13BC-885A7089D2CA}"/>
               </a:ext>
             </a:extLst>
           </p:cNvPr>
@@ -4572,14 +5513,43 @@
         </p:blipFill>
         <p:spPr>
           <a:xfrm>
-            <a:off x="1371939" y="875381"/>
-            <a:ext cx="7336745" cy="3919787"/>
+            <a:off x="1058695" y="945190"/>
+            <a:ext cx="8637987" cy="3833544"/>
           </a:xfrm>
           <a:prstGeom prst="rect">
             <a:avLst/>
           </a:prstGeom>
         </p:spPr>
       </p:pic>
+      <p:sp>
+        <p:nvSpPr>
+          <p:cNvPr id="5" name="Slide Number Placeholder 4">
+            <a:extLst>
+              <a:ext uri="{FF2B5EF4-FFF2-40B4-BE49-F238E27FC236}">
+                <a16:creationId xmlns:a16="http://schemas.microsoft.com/office/drawing/2014/main" id="{D7CA5B91-7564-848E-B4A1-9273C3672979}"/>
+              </a:ext>
+            </a:extLst>
+          </p:cNvPr>
+          <p:cNvSpPr>
+            <a:spLocks noGrp="1"/>
+          </p:cNvSpPr>
+          <p:nvPr>
+            <p:ph type="sldNum" idx="2"/>
+          </p:nvPr>
+        </p:nvSpPr>
+        <p:spPr/>
+        <p:txBody>
+          <a:bodyPr/>
+          <a:lstStyle/>
+          <a:p>
+            <a:fld id="{B99B1A2D-D4B6-4047-AD69-D754256AF902}" type="slidenum">
+              <a:rPr lang="en-MX" smtClean="0"/>
+              <a:t>13</a:t>
+            </a:fld>
+            <a:endParaRPr lang="en-MX"/>
+          </a:p>
+        </p:txBody>
+      </p:sp>
     </p:spTree>
   </p:cSld>
   <p:clrMapOvr>
@@ -4588,7 +5558,7 @@
 </p:sld>
 </file>
 
-<file path=ppt/slides/slide11.xml><?xml version="1.0" encoding="utf-8"?>
+<file path=ppt/slides/slide14.xml><?xml version="1.0" encoding="utf-8"?>
 <p:sld xmlns:a="http://schemas.openxmlformats.org/drawingml/2006/main" xmlns:r="http://schemas.openxmlformats.org/officeDocument/2006/relationships" xmlns:p="http://schemas.openxmlformats.org/presentationml/2006/main">
   <p:cSld>
     <p:spTree>
@@ -4698,7 +5668,7 @@
               </a:tabLst>
             </a:pPr>
             <a:r>
-              <a:rPr lang="es-ES" sz="2600" b="1" strike="noStrike" spc="-1">
+              <a:rPr lang="es-ES" sz="2600" b="1" strike="noStrike" spc="-1" dirty="0">
                 <a:solidFill>
                   <a:srgbClr val="000000"/>
                 </a:solidFill>
@@ -4707,7 +5677,7 @@
               </a:rPr>
               <a:t>Referencias </a:t>
             </a:r>
-            <a:endParaRPr lang="es-MX" sz="2600" b="0" strike="noStrike" spc="-1">
+            <a:endParaRPr lang="es-MX" sz="2600" b="0" strike="noStrike" spc="-1" dirty="0">
               <a:latin typeface="Arial"/>
             </a:endParaRPr>
           </a:p>
@@ -5978,72 +6948,30 @@
       </p:sp>
       <p:sp>
         <p:nvSpPr>
-          <p:cNvPr id="135" name="PlaceHolder 1"/>
+          <p:cNvPr id="2" name="Slide Number Placeholder 1">
+            <a:extLst>
+              <a:ext uri="{FF2B5EF4-FFF2-40B4-BE49-F238E27FC236}">
+                <a16:creationId xmlns:a16="http://schemas.microsoft.com/office/drawing/2014/main" id="{007AD380-86D5-91BF-5CEA-034D5AC6677E}"/>
+              </a:ext>
+            </a:extLst>
+          </p:cNvPr>
           <p:cNvSpPr>
             <a:spLocks noGrp="1"/>
           </p:cNvSpPr>
           <p:nvPr>
-            <p:ph type="sldNum" idx="19"/>
+            <p:ph type="sldNum" idx="2"/>
           </p:nvPr>
         </p:nvSpPr>
-        <p:spPr>
-          <a:xfrm>
-            <a:off x="7227360" y="5165280"/>
-            <a:ext cx="2347920" cy="390240"/>
-          </a:xfrm>
-          <a:prstGeom prst="rect">
-            <a:avLst/>
-          </a:prstGeom>
-          <a:noFill/>
-          <a:ln w="0">
-            <a:noFill/>
-          </a:ln>
-        </p:spPr>
-        <p:txBody>
-          <a:bodyPr lIns="0" tIns="0" rIns="0" bIns="0" anchor="t">
-            <a:noAutofit/>
-          </a:bodyPr>
-          <a:lstStyle>
-            <a:lvl1pPr algn="r">
-              <a:lnSpc>
-                <a:spcPct val="100000"/>
-              </a:lnSpc>
-              <a:buNone/>
-              <a:tabLst>
-                <a:tab pos="0" algn="l"/>
-              </a:tabLst>
-              <a:defRPr lang="es-ES" sz="1400" b="0" strike="noStrike" spc="-1">
-                <a:solidFill>
-                  <a:srgbClr val="000000"/>
-                </a:solidFill>
-                <a:latin typeface="Times New Roman"/>
-                <a:ea typeface="Times New Roman"/>
-              </a:defRPr>
-            </a:lvl1pPr>
-          </a:lstStyle>
-          <a:p>
-            <a:pPr algn="r">
-              <a:lnSpc>
-                <a:spcPct val="100000"/>
-              </a:lnSpc>
-              <a:buNone/>
-              <a:tabLst>
-                <a:tab pos="0" algn="l"/>
-              </a:tabLst>
-            </a:pPr>
-            <a:r>
-              <a:rPr lang="es-ES" sz="1400" b="0" strike="noStrike" spc="-1" dirty="0">
-                <a:solidFill>
-                  <a:srgbClr val="000000"/>
-                </a:solidFill>
-                <a:latin typeface="Times New Roman"/>
-                <a:ea typeface="Times New Roman"/>
-              </a:rPr>
-              <a:t>15/16</a:t>
-            </a:r>
-            <a:endParaRPr lang="es-MX" sz="1400" b="0" strike="noStrike" spc="-1" dirty="0">
-              <a:latin typeface="Times New Roman"/>
-            </a:endParaRPr>
+        <p:spPr/>
+        <p:txBody>
+          <a:bodyPr/>
+          <a:lstStyle/>
+          <a:p>
+            <a:fld id="{B99B1A2D-D4B6-4047-AD69-D754256AF902}" type="slidenum">
+              <a:rPr lang="en-MX" smtClean="0"/>
+              <a:t>14</a:t>
+            </a:fld>
+            <a:endParaRPr lang="en-MX"/>
           </a:p>
         </p:txBody>
       </p:sp>
@@ -6055,7 +6983,7 @@
 </p:sld>
 </file>
 
-<file path=ppt/slides/slide12.xml><?xml version="1.0" encoding="utf-8"?>
+<file path=ppt/slides/slide15.xml><?xml version="1.0" encoding="utf-8"?>
 <p:sld xmlns:a="http://schemas.openxmlformats.org/drawingml/2006/main" xmlns:r="http://schemas.openxmlformats.org/officeDocument/2006/relationships" xmlns:p="http://schemas.openxmlformats.org/presentationml/2006/main">
   <p:cSld>
     <p:spTree>
@@ -6587,10 +7515,10 @@
       </p:pic>
       <p:sp>
         <p:nvSpPr>
-          <p:cNvPr id="2" name="Slide Number Placeholder 1">
+          <p:cNvPr id="3" name="Slide Number Placeholder 2">
             <a:extLst>
               <a:ext uri="{FF2B5EF4-FFF2-40B4-BE49-F238E27FC236}">
-                <a16:creationId xmlns:a16="http://schemas.microsoft.com/office/drawing/2014/main" id="{836B97FF-AE70-9A06-F3A5-5340E8EF32D2}"/>
+                <a16:creationId xmlns:a16="http://schemas.microsoft.com/office/drawing/2014/main" id="{3B075C1E-A4F2-24D0-978B-9E389FAE08CD}"/>
               </a:ext>
             </a:extLst>
           </p:cNvPr>
@@ -6608,7 +7536,7 @@
           <a:p>
             <a:fld id="{B99B1A2D-D4B6-4047-AD69-D754256AF902}" type="slidenum">
               <a:rPr lang="en-MX" smtClean="0"/>
-              <a:t>12</a:t>
+              <a:t>15</a:t>
             </a:fld>
             <a:endParaRPr lang="en-MX"/>
           </a:p>
@@ -6720,7 +7648,8 @@
               </a:lnSpc>
             </a:pPr>
             <a:endParaRPr lang="es-MX" sz="2000" b="0" strike="noStrike" spc="-1" dirty="0">
-              <a:latin typeface="Arial"/>
+              <a:latin typeface="Calibri" panose="020F0502020204030204" pitchFamily="34" charset="0"/>
+              <a:cs typeface="Calibri" panose="020F0502020204030204" pitchFamily="34" charset="0"/>
             </a:endParaRPr>
           </a:p>
           <a:p>
@@ -6739,13 +7668,15 @@
                 <a:solidFill>
                   <a:srgbClr val="000000"/>
                 </a:solidFill>
-                <a:latin typeface="Calibri"/>
+                <a:latin typeface="Calibri" panose="020F0502020204030204" pitchFamily="34" charset="0"/>
                 <a:ea typeface="Calibri"/>
+                <a:cs typeface="Calibri" panose="020F0502020204030204" pitchFamily="34" charset="0"/>
               </a:rPr>
               <a:t>Planteamiento del problema</a:t>
             </a:r>
             <a:endParaRPr lang="es-MX" sz="2000" b="0" strike="noStrike" spc="-1" dirty="0">
-              <a:latin typeface="Arial"/>
+              <a:latin typeface="Calibri" panose="020F0502020204030204" pitchFamily="34" charset="0"/>
+              <a:cs typeface="Calibri" panose="020F0502020204030204" pitchFamily="34" charset="0"/>
             </a:endParaRPr>
           </a:p>
           <a:p>
@@ -6757,7 +7688,8 @@
               <a:buAutoNum type="arabicPeriod"/>
             </a:pPr>
             <a:endParaRPr lang="es-MX" sz="2000" b="0" strike="noStrike" spc="-1" dirty="0">
-              <a:latin typeface="Arial"/>
+              <a:latin typeface="Calibri" panose="020F0502020204030204" pitchFamily="34" charset="0"/>
+              <a:cs typeface="Calibri" panose="020F0502020204030204" pitchFamily="34" charset="0"/>
             </a:endParaRPr>
           </a:p>
           <a:p>
@@ -6776,13 +7708,15 @@
                 <a:solidFill>
                   <a:srgbClr val="000000"/>
                 </a:solidFill>
-                <a:latin typeface="Calibri"/>
+                <a:latin typeface="Calibri" panose="020F0502020204030204" pitchFamily="34" charset="0"/>
                 <a:ea typeface="Calibri"/>
+                <a:cs typeface="Calibri" panose="020F0502020204030204" pitchFamily="34" charset="0"/>
               </a:rPr>
               <a:t>Objetivo General</a:t>
             </a:r>
             <a:endParaRPr lang="es-MX" sz="2000" b="0" strike="noStrike" spc="-1" dirty="0">
-              <a:latin typeface="Arial"/>
+              <a:latin typeface="Calibri" panose="020F0502020204030204" pitchFamily="34" charset="0"/>
+              <a:cs typeface="Calibri" panose="020F0502020204030204" pitchFamily="34" charset="0"/>
             </a:endParaRPr>
           </a:p>
           <a:p>
@@ -6794,7 +7728,8 @@
               <a:buAutoNum type="arabicPeriod"/>
             </a:pPr>
             <a:endParaRPr lang="es-MX" sz="2000" b="0" strike="noStrike" spc="-1" dirty="0">
-              <a:latin typeface="Arial"/>
+              <a:latin typeface="Calibri" panose="020F0502020204030204" pitchFamily="34" charset="0"/>
+              <a:cs typeface="Calibri" panose="020F0502020204030204" pitchFamily="34" charset="0"/>
             </a:endParaRPr>
           </a:p>
           <a:p>
@@ -6813,27 +7748,67 @@
                 <a:solidFill>
                   <a:srgbClr val="000000"/>
                 </a:solidFill>
-                <a:latin typeface="Calibri"/>
+                <a:latin typeface="Calibri" panose="020F0502020204030204" pitchFamily="34" charset="0"/>
                 <a:ea typeface="Calibri"/>
-              </a:rPr>
-              <a:t>Hipótesis y Justificación</a:t>
-            </a:r>
+                <a:cs typeface="Calibri" panose="020F0502020204030204" pitchFamily="34" charset="0"/>
+              </a:rPr>
+              <a:t>Hipótesis </a:t>
+            </a:r>
+            <a:endParaRPr lang="es-ES" sz="2000" spc="-1" dirty="0">
+              <a:solidFill>
+                <a:srgbClr val="000000"/>
+              </a:solidFill>
+              <a:latin typeface="Calibri" panose="020F0502020204030204" pitchFamily="34" charset="0"/>
+              <a:ea typeface="Calibri"/>
+              <a:cs typeface="Calibri" panose="020F0502020204030204" pitchFamily="34" charset="0"/>
+            </a:endParaRPr>
+          </a:p>
+          <a:p>
+            <a:pPr marL="457200" indent="-457200" algn="just">
+              <a:lnSpc>
+                <a:spcPct val="90000"/>
+              </a:lnSpc>
+              <a:buClr>
+                <a:srgbClr val="000000"/>
+              </a:buClr>
+              <a:buFont typeface="+mj-lt"/>
+              <a:buAutoNum type="arabicPeriod"/>
+            </a:pPr>
+            <a:endParaRPr lang="es-ES" sz="2000" spc="-1" dirty="0">
+              <a:solidFill>
+                <a:srgbClr val="000000"/>
+              </a:solidFill>
+              <a:latin typeface="Calibri" panose="020F0502020204030204" pitchFamily="34" charset="0"/>
+              <a:ea typeface="Calibri"/>
+              <a:cs typeface="Calibri" panose="020F0502020204030204" pitchFamily="34" charset="0"/>
+            </a:endParaRPr>
+          </a:p>
+          <a:p>
+            <a:pPr marL="457200" indent="-457200" algn="just">
+              <a:buClr>
+                <a:srgbClr val="000000"/>
+              </a:buClr>
+              <a:buFont typeface="+mj-lt"/>
+              <a:buAutoNum type="arabicPeriod"/>
+            </a:pPr>
             <a:r>
               <a:rPr lang="es-ES" sz="2000" spc="-1" dirty="0">
                 <a:solidFill>
                   <a:srgbClr val="000000"/>
                 </a:solidFill>
-                <a:latin typeface="Calibri"/>
+                <a:latin typeface="Calibri" panose="020F0502020204030204" pitchFamily="34" charset="0"/>
                 <a:ea typeface="Calibri"/>
-              </a:rPr>
-              <a:t> </a:t>
+                <a:cs typeface="Calibri" panose="020F0502020204030204" pitchFamily="34" charset="0"/>
+              </a:rPr>
+              <a:t>Justificación</a:t>
             </a:r>
             <a:endParaRPr lang="es-MX" sz="2000" spc="-1" dirty="0">
               <a:solidFill>
                 <a:srgbClr val="000000"/>
               </a:solidFill>
-              <a:latin typeface="Arial"/>
+              <a:latin typeface="Calibri" panose="020F0502020204030204" pitchFamily="34" charset="0"/>
               <a:ea typeface="Calibri"/>
+              <a:cs typeface="Calibri" panose="020F0502020204030204" pitchFamily="34" charset="0"/>
             </a:endParaRPr>
           </a:p>
           <a:p>
@@ -6848,7 +7823,8 @@
               <a:buAutoNum type="arabicPeriod"/>
             </a:pPr>
             <a:endParaRPr lang="es-MX" sz="2000" b="0" strike="noStrike" spc="-1" dirty="0">
-              <a:latin typeface="Arial"/>
+              <a:latin typeface="Calibri" panose="020F0502020204030204" pitchFamily="34" charset="0"/>
+              <a:cs typeface="Calibri" panose="020F0502020204030204" pitchFamily="34" charset="0"/>
             </a:endParaRPr>
           </a:p>
           <a:p>
@@ -6867,13 +7843,15 @@
                 <a:solidFill>
                   <a:srgbClr val="000000"/>
                 </a:solidFill>
-                <a:latin typeface="Calibri"/>
+                <a:latin typeface="Calibri" panose="020F0502020204030204" pitchFamily="34" charset="0"/>
                 <a:ea typeface="Calibri"/>
+                <a:cs typeface="Calibri" panose="020F0502020204030204" pitchFamily="34" charset="0"/>
               </a:rPr>
               <a:t>Redes Neuronales Artificiales</a:t>
             </a:r>
             <a:endParaRPr lang="es-MX" sz="2000" b="0" strike="noStrike" spc="-1" dirty="0">
-              <a:latin typeface="Arial"/>
+              <a:latin typeface="Calibri" panose="020F0502020204030204" pitchFamily="34" charset="0"/>
+              <a:cs typeface="Calibri" panose="020F0502020204030204" pitchFamily="34" charset="0"/>
             </a:endParaRPr>
           </a:p>
           <a:p>
@@ -6891,8 +7869,9 @@
               <a:solidFill>
                 <a:srgbClr val="000000"/>
               </a:solidFill>
-              <a:latin typeface="Calibri"/>
+              <a:latin typeface="Calibri" panose="020F0502020204030204" pitchFamily="34" charset="0"/>
               <a:ea typeface="Calibri"/>
+              <a:cs typeface="Calibri" panose="020F0502020204030204" pitchFamily="34" charset="0"/>
             </a:endParaRPr>
           </a:p>
           <a:p>
@@ -6911,8 +7890,9 @@
                 <a:solidFill>
                   <a:srgbClr val="000000"/>
                 </a:solidFill>
-                <a:latin typeface="Calibri"/>
+                <a:latin typeface="Calibri" panose="020F0502020204030204" pitchFamily="34" charset="0"/>
                 <a:ea typeface="Calibri"/>
+                <a:cs typeface="Calibri" panose="020F0502020204030204" pitchFamily="34" charset="0"/>
               </a:rPr>
               <a:t>Backpropagation</a:t>
             </a:r>
@@ -6920,8 +7900,9 @@
               <a:solidFill>
                 <a:srgbClr val="000000"/>
               </a:solidFill>
-              <a:latin typeface="Calibri"/>
+              <a:latin typeface="Calibri" panose="020F0502020204030204" pitchFamily="34" charset="0"/>
               <a:ea typeface="Calibri"/>
+              <a:cs typeface="Calibri" panose="020F0502020204030204" pitchFamily="34" charset="0"/>
             </a:endParaRPr>
           </a:p>
           <a:p>
@@ -6939,8 +7920,9 @@
               <a:solidFill>
                 <a:srgbClr val="000000"/>
               </a:solidFill>
-              <a:latin typeface="Calibri"/>
+              <a:latin typeface="Calibri" panose="020F0502020204030204" pitchFamily="34" charset="0"/>
               <a:ea typeface="Calibri"/>
+              <a:cs typeface="Calibri" panose="020F0502020204030204" pitchFamily="34" charset="0"/>
             </a:endParaRPr>
           </a:p>
           <a:p>
@@ -6959,17 +7941,104 @@
                 <a:solidFill>
                   <a:srgbClr val="000000"/>
                 </a:solidFill>
-                <a:latin typeface="Calibri"/>
+                <a:latin typeface="Calibri" panose="020F0502020204030204" pitchFamily="34" charset="0"/>
                 <a:ea typeface="Calibri"/>
+                <a:cs typeface="Calibri" panose="020F0502020204030204" pitchFamily="34" charset="0"/>
               </a:rPr>
               <a:t>Aprendizaje Incremental</a:t>
+            </a:r>
+          </a:p>
+          <a:p>
+            <a:pPr marL="457200" indent="-457200" algn="just">
+              <a:lnSpc>
+                <a:spcPct val="90000"/>
+              </a:lnSpc>
+              <a:buClr>
+                <a:srgbClr val="000000"/>
+              </a:buClr>
+              <a:buFont typeface="+mj-lt"/>
+              <a:buAutoNum type="arabicPeriod"/>
+            </a:pPr>
+            <a:endParaRPr lang="es-ES" sz="2000" spc="-1" dirty="0">
+              <a:solidFill>
+                <a:srgbClr val="000000"/>
+              </a:solidFill>
+              <a:latin typeface="Calibri" panose="020F0502020204030204" pitchFamily="34" charset="0"/>
+              <a:ea typeface="Calibri"/>
+              <a:cs typeface="Calibri" panose="020F0502020204030204" pitchFamily="34" charset="0"/>
+            </a:endParaRPr>
+          </a:p>
+          <a:p>
+            <a:pPr marL="457200" indent="-457200" algn="just">
+              <a:buClr>
+                <a:srgbClr val="000000"/>
+              </a:buClr>
+              <a:buFont typeface="+mj-lt"/>
+              <a:buAutoNum type="arabicPeriod"/>
+            </a:pPr>
+            <a:r>
+              <a:rPr lang="en-US" sz="2000" dirty="0" err="1">
+                <a:latin typeface="Calibri" panose="020F0502020204030204" pitchFamily="34" charset="0"/>
+                <a:cs typeface="Calibri" panose="020F0502020204030204" pitchFamily="34" charset="0"/>
+              </a:rPr>
+              <a:t>Arquitectura</a:t>
+            </a:r>
+            <a:r>
+              <a:rPr lang="en-US" sz="2000" dirty="0">
+                <a:latin typeface="Calibri" panose="020F0502020204030204" pitchFamily="34" charset="0"/>
+                <a:cs typeface="Calibri" panose="020F0502020204030204" pitchFamily="34" charset="0"/>
+              </a:rPr>
+              <a:t> de </a:t>
+            </a:r>
+            <a:r>
+              <a:rPr lang="en-US" sz="2000" dirty="0" err="1">
+                <a:latin typeface="Calibri" panose="020F0502020204030204" pitchFamily="34" charset="0"/>
+                <a:cs typeface="Calibri" panose="020F0502020204030204" pitchFamily="34" charset="0"/>
+              </a:rPr>
+              <a:t>referencia</a:t>
+            </a:r>
+            <a:r>
+              <a:rPr lang="en-US" sz="2000" dirty="0">
+                <a:latin typeface="Calibri" panose="020F0502020204030204" pitchFamily="34" charset="0"/>
+                <a:cs typeface="Calibri" panose="020F0502020204030204" pitchFamily="34" charset="0"/>
+              </a:rPr>
+              <a:t> para </a:t>
+            </a:r>
+            <a:r>
+              <a:rPr lang="en-US" sz="2000" dirty="0" err="1">
+                <a:latin typeface="Calibri" panose="020F0502020204030204" pitchFamily="34" charset="0"/>
+                <a:cs typeface="Calibri" panose="020F0502020204030204" pitchFamily="34" charset="0"/>
+              </a:rPr>
+              <a:t>el</a:t>
+            </a:r>
+            <a:r>
+              <a:rPr lang="en-US" sz="2000" dirty="0">
+                <a:latin typeface="Calibri" panose="020F0502020204030204" pitchFamily="34" charset="0"/>
+                <a:cs typeface="Calibri" panose="020F0502020204030204" pitchFamily="34" charset="0"/>
+              </a:rPr>
+              <a:t> </a:t>
+            </a:r>
+            <a:r>
+              <a:rPr lang="en-US" sz="2000" dirty="0" err="1">
+                <a:latin typeface="Calibri" panose="020F0502020204030204" pitchFamily="34" charset="0"/>
+                <a:cs typeface="Calibri" panose="020F0502020204030204" pitchFamily="34" charset="0"/>
+              </a:rPr>
+              <a:t>esquema</a:t>
+            </a:r>
+            <a:r>
+              <a:rPr lang="en-US" sz="2000" dirty="0">
+                <a:latin typeface="Calibri" panose="020F0502020204030204" pitchFamily="34" charset="0"/>
+                <a:cs typeface="Calibri" panose="020F0502020204030204" pitchFamily="34" charset="0"/>
+              </a:rPr>
+              <a:t> incremental</a:t>
             </a:r>
             <a:endParaRPr lang="es-MX" sz="2000" spc="-1" dirty="0">
               <a:solidFill>
                 <a:srgbClr val="000000"/>
               </a:solidFill>
-              <a:latin typeface="Arial"/>
+              <a:latin typeface="Calibri" panose="020F0502020204030204" pitchFamily="34" charset="0"/>
               <a:ea typeface="Calibri"/>
+              <a:cs typeface="Calibri" panose="020F0502020204030204" pitchFamily="34" charset="0"/>
             </a:endParaRPr>
           </a:p>
           <a:p>
@@ -6984,7 +8053,8 @@
               <a:buAutoNum type="arabicPeriod"/>
             </a:pPr>
             <a:endParaRPr lang="es-MX" sz="2000" b="0" strike="noStrike" spc="-1" dirty="0">
-              <a:latin typeface="Arial"/>
+              <a:latin typeface="Calibri" panose="020F0502020204030204" pitchFamily="34" charset="0"/>
+              <a:cs typeface="Calibri" panose="020F0502020204030204" pitchFamily="34" charset="0"/>
             </a:endParaRPr>
           </a:p>
           <a:p>
@@ -7003,26 +8073,12 @@
                 <a:solidFill>
                   <a:srgbClr val="000000"/>
                 </a:solidFill>
-                <a:latin typeface="Calibri"/>
+                <a:latin typeface="Calibri" panose="020F0502020204030204" pitchFamily="34" charset="0"/>
                 <a:ea typeface="Calibri"/>
+                <a:cs typeface="Calibri" panose="020F0502020204030204" pitchFamily="34" charset="0"/>
               </a:rPr>
               <a:t>Metodología</a:t>
             </a:r>
-            <a:endParaRPr lang="es-MX" sz="2000" b="0" strike="noStrike" spc="-1" dirty="0">
-              <a:latin typeface="Arial"/>
-            </a:endParaRPr>
-          </a:p>
-          <a:p>
-            <a:pPr marL="457200" indent="-457200" algn="just">
-              <a:lnSpc>
-                <a:spcPct val="90000"/>
-              </a:lnSpc>
-              <a:buFont typeface="+mj-lt"/>
-              <a:buAutoNum type="arabicPeriod"/>
-            </a:pPr>
-            <a:endParaRPr lang="es-MX" sz="2000" b="0" strike="noStrike" spc="-1" dirty="0">
-              <a:latin typeface="Arial"/>
-            </a:endParaRPr>
           </a:p>
           <a:p>
             <a:pPr marL="457200" indent="-457200" algn="just">
@@ -7035,18 +8091,128 @@
               <a:buFont typeface="+mj-lt"/>
               <a:buAutoNum type="arabicPeriod"/>
             </a:pPr>
+            <a:endParaRPr lang="es-ES" sz="2000" spc="-1" dirty="0">
+              <a:solidFill>
+                <a:srgbClr val="000000"/>
+              </a:solidFill>
+              <a:latin typeface="Calibri" panose="020F0502020204030204" pitchFamily="34" charset="0"/>
+              <a:cs typeface="Calibri" panose="020F0502020204030204" pitchFamily="34" charset="0"/>
+            </a:endParaRPr>
+          </a:p>
+          <a:p>
+            <a:pPr marL="457200" indent="-457200" algn="just">
+              <a:buClr>
+                <a:srgbClr val="000000"/>
+              </a:buClr>
+              <a:buFont typeface="+mj-lt"/>
+              <a:buAutoNum type="arabicPeriod"/>
+            </a:pPr>
+            <a:r>
+              <a:rPr lang="en-US" sz="2000" dirty="0" err="1">
+                <a:latin typeface="Calibri" panose="020F0502020204030204" pitchFamily="34" charset="0"/>
+                <a:cs typeface="Calibri" panose="020F0502020204030204" pitchFamily="34" charset="0"/>
+              </a:rPr>
+              <a:t>Resultados</a:t>
+            </a:r>
+            <a:r>
+              <a:rPr lang="en-US" sz="2000" dirty="0">
+                <a:latin typeface="Calibri" panose="020F0502020204030204" pitchFamily="34" charset="0"/>
+                <a:cs typeface="Calibri" panose="020F0502020204030204" pitchFamily="34" charset="0"/>
+              </a:rPr>
+              <a:t> de la </a:t>
+            </a:r>
+            <a:r>
+              <a:rPr lang="en-US" sz="2000" dirty="0" err="1">
+                <a:latin typeface="Calibri" panose="020F0502020204030204" pitchFamily="34" charset="0"/>
+                <a:cs typeface="Calibri" panose="020F0502020204030204" pitchFamily="34" charset="0"/>
+              </a:rPr>
+              <a:t>Réplica</a:t>
+            </a:r>
+            <a:r>
+              <a:rPr lang="en-US" sz="2000" dirty="0">
+                <a:latin typeface="Calibri" panose="020F0502020204030204" pitchFamily="34" charset="0"/>
+                <a:cs typeface="Calibri" panose="020F0502020204030204" pitchFamily="34" charset="0"/>
+              </a:rPr>
+              <a:t> del Modelo de </a:t>
+            </a:r>
+            <a:r>
+              <a:rPr lang="en-US" sz="2000" dirty="0" err="1">
+                <a:latin typeface="Calibri" panose="020F0502020204030204" pitchFamily="34" charset="0"/>
+                <a:cs typeface="Calibri" panose="020F0502020204030204" pitchFamily="34" charset="0"/>
+              </a:rPr>
+              <a:t>Bullinaria</a:t>
+            </a:r>
+            <a:r>
+              <a:rPr lang="en-US" sz="2000" dirty="0">
+                <a:latin typeface="Calibri" panose="020F0502020204030204" pitchFamily="34" charset="0"/>
+                <a:cs typeface="Calibri" panose="020F0502020204030204" pitchFamily="34" charset="0"/>
+              </a:rPr>
+              <a:t> </a:t>
+            </a:r>
+            <a:r>
+              <a:rPr lang="en-US" sz="2000" dirty="0" err="1">
+                <a:latin typeface="Calibri" panose="020F0502020204030204" pitchFamily="34" charset="0"/>
+                <a:cs typeface="Calibri" panose="020F0502020204030204" pitchFamily="34" charset="0"/>
+              </a:rPr>
+              <a:t>en</a:t>
+            </a:r>
+            <a:r>
+              <a:rPr lang="en-US" sz="2000" dirty="0">
+                <a:latin typeface="Calibri" panose="020F0502020204030204" pitchFamily="34" charset="0"/>
+                <a:cs typeface="Calibri" panose="020F0502020204030204" pitchFamily="34" charset="0"/>
+              </a:rPr>
+              <a:t> </a:t>
+            </a:r>
+            <a:r>
+              <a:rPr lang="en-US" sz="2000" dirty="0" err="1">
+                <a:latin typeface="Calibri" panose="020F0502020204030204" pitchFamily="34" charset="0"/>
+                <a:cs typeface="Calibri" panose="020F0502020204030204" pitchFamily="34" charset="0"/>
+              </a:rPr>
+              <a:t>PyTorch</a:t>
+            </a:r>
+            <a:endParaRPr lang="es-MX" sz="2000" b="0" strike="noStrike" spc="-1" dirty="0">
+              <a:latin typeface="Calibri" panose="020F0502020204030204" pitchFamily="34" charset="0"/>
+              <a:cs typeface="Calibri" panose="020F0502020204030204" pitchFamily="34" charset="0"/>
+            </a:endParaRPr>
+          </a:p>
+          <a:p>
+            <a:pPr marL="457200" indent="-457200" algn="just">
+              <a:lnSpc>
+                <a:spcPct val="90000"/>
+              </a:lnSpc>
+              <a:buFont typeface="+mj-lt"/>
+              <a:buAutoNum type="arabicPeriod"/>
+            </a:pPr>
+            <a:endParaRPr lang="es-MX" sz="2000" b="0" strike="noStrike" spc="-1" dirty="0">
+              <a:latin typeface="Calibri" panose="020F0502020204030204" pitchFamily="34" charset="0"/>
+              <a:cs typeface="Calibri" panose="020F0502020204030204" pitchFamily="34" charset="0"/>
+            </a:endParaRPr>
+          </a:p>
+          <a:p>
+            <a:pPr marL="457200" indent="-457200" algn="just">
+              <a:lnSpc>
+                <a:spcPct val="90000"/>
+              </a:lnSpc>
+              <a:buClr>
+                <a:srgbClr val="000000"/>
+              </a:buClr>
+              <a:buFont typeface="+mj-lt"/>
+              <a:buAutoNum type="arabicPeriod"/>
+            </a:pPr>
             <a:r>
               <a:rPr lang="es-ES" sz="2000" b="0" strike="noStrike" spc="-1" dirty="0">
                 <a:solidFill>
                   <a:srgbClr val="000000"/>
                 </a:solidFill>
-                <a:latin typeface="Calibri"/>
+                <a:latin typeface="Calibri" panose="020F0502020204030204" pitchFamily="34" charset="0"/>
                 <a:ea typeface="Calibri"/>
+                <a:cs typeface="Calibri" panose="020F0502020204030204" pitchFamily="34" charset="0"/>
               </a:rPr>
               <a:t>Cronograma de Actividades</a:t>
             </a:r>
             <a:endParaRPr lang="es-MX" sz="2000" b="0" strike="noStrike" spc="-1" dirty="0">
-              <a:latin typeface="Arial"/>
+              <a:latin typeface="Calibri" panose="020F0502020204030204" pitchFamily="34" charset="0"/>
+              <a:cs typeface="Calibri" panose="020F0502020204030204" pitchFamily="34" charset="0"/>
             </a:endParaRPr>
           </a:p>
         </p:txBody>
@@ -7110,72 +8276,30 @@
       </p:sp>
       <p:sp>
         <p:nvSpPr>
-          <p:cNvPr id="52" name="PlaceHolder 3"/>
+          <p:cNvPr id="2" name="Slide Number Placeholder 1">
+            <a:extLst>
+              <a:ext uri="{FF2B5EF4-FFF2-40B4-BE49-F238E27FC236}">
+                <a16:creationId xmlns:a16="http://schemas.microsoft.com/office/drawing/2014/main" id="{CDCBCF2D-A0E2-0A74-7141-A4202BCE52C1}"/>
+              </a:ext>
+            </a:extLst>
+          </p:cNvPr>
           <p:cNvSpPr>
             <a:spLocks noGrp="1"/>
           </p:cNvSpPr>
           <p:nvPr>
-            <p:ph type="sldNum" idx="4"/>
+            <p:ph type="sldNum" idx="2"/>
           </p:nvPr>
         </p:nvSpPr>
-        <p:spPr>
-          <a:xfrm>
-            <a:off x="7227360" y="5165280"/>
-            <a:ext cx="2347920" cy="390240"/>
-          </a:xfrm>
-          <a:prstGeom prst="rect">
-            <a:avLst/>
-          </a:prstGeom>
-          <a:noFill/>
-          <a:ln w="0">
-            <a:noFill/>
-          </a:ln>
-        </p:spPr>
-        <p:txBody>
-          <a:bodyPr lIns="0" tIns="0" rIns="0" bIns="0" anchor="t">
-            <a:noAutofit/>
-          </a:bodyPr>
-          <a:lstStyle>
-            <a:lvl1pPr algn="r">
-              <a:lnSpc>
-                <a:spcPct val="100000"/>
-              </a:lnSpc>
-              <a:buNone/>
-              <a:tabLst>
-                <a:tab pos="0" algn="l"/>
-              </a:tabLst>
-              <a:defRPr lang="es-ES" sz="1400" b="0" strike="noStrike" spc="-1">
-                <a:solidFill>
-                  <a:srgbClr val="000000"/>
-                </a:solidFill>
-                <a:latin typeface="Times New Roman"/>
-                <a:ea typeface="Times New Roman"/>
-              </a:defRPr>
-            </a:lvl1pPr>
-          </a:lstStyle>
-          <a:p>
-            <a:pPr algn="r">
-              <a:lnSpc>
-                <a:spcPct val="100000"/>
-              </a:lnSpc>
-              <a:buNone/>
-              <a:tabLst>
-                <a:tab pos="0" algn="l"/>
-              </a:tabLst>
-            </a:pPr>
-            <a:r>
-              <a:rPr lang="es-ES" sz="1400" b="0" strike="noStrike" spc="-1" dirty="0">
-                <a:solidFill>
-                  <a:srgbClr val="000000"/>
-                </a:solidFill>
-                <a:latin typeface="Times New Roman"/>
-                <a:ea typeface="Times New Roman"/>
-              </a:rPr>
-              <a:t>2/16</a:t>
-            </a:r>
-            <a:endParaRPr lang="es-MX" sz="1400" b="0" strike="noStrike" spc="-1" dirty="0">
-              <a:latin typeface="Times New Roman"/>
-            </a:endParaRPr>
+        <p:spPr/>
+        <p:txBody>
+          <a:bodyPr/>
+          <a:lstStyle/>
+          <a:p>
+            <a:fld id="{B99B1A2D-D4B6-4047-AD69-D754256AF902}" type="slidenum">
+              <a:rPr lang="en-MX" smtClean="0"/>
+              <a:t>2</a:t>
+            </a:fld>
+            <a:endParaRPr lang="en-MX"/>
           </a:p>
         </p:txBody>
       </p:sp>
@@ -7300,7 +8424,7 @@
                 <a:latin typeface="Calibri"/>
                 <a:ea typeface="Calibri"/>
               </a:rPr>
-              <a:t>	- Tasa de aprendizaje alta</a:t>
+              <a:t>		- Tasa de aprendizaje alta</a:t>
             </a:r>
             <a:endParaRPr lang="es-MX" sz="2400" b="0" strike="noStrike" spc="-1" dirty="0">
               <a:latin typeface="Arial"/>
@@ -7352,7 +8476,7 @@
                 <a:latin typeface="Calibri"/>
                 <a:ea typeface="Calibri"/>
               </a:rPr>
-              <a:t>	- Tasa de aprendizaje pequeña</a:t>
+              <a:t>		- Tasa de aprendizaje pequeña</a:t>
             </a:r>
             <a:endParaRPr lang="es-MX" sz="2400" b="0" strike="noStrike" spc="-1" dirty="0">
               <a:latin typeface="Arial"/>
@@ -7503,7 +8627,7 @@
               </a:tabLst>
             </a:pPr>
             <a:r>
-              <a:rPr lang="es-ES" sz="2600" b="1" strike="noStrike" spc="-1">
+              <a:rPr lang="es-ES" sz="2600" b="1" strike="noStrike" spc="-1" dirty="0">
                 <a:solidFill>
                   <a:srgbClr val="000000"/>
                 </a:solidFill>
@@ -7512,7 +8636,7 @@
               </a:rPr>
               <a:t>Planteamiento del Problema</a:t>
             </a:r>
-            <a:endParaRPr lang="es-MX" sz="2600" b="0" strike="noStrike" spc="-1">
+            <a:endParaRPr lang="es-MX" sz="2600" b="0" strike="noStrike" spc="-1" dirty="0">
               <a:solidFill>
                 <a:srgbClr val="000000"/>
               </a:solidFill>
@@ -7523,82 +8647,30 @@
       </p:sp>
       <p:sp>
         <p:nvSpPr>
-          <p:cNvPr id="62" name="PlaceHolder 3"/>
+          <p:cNvPr id="2" name="Slide Number Placeholder 1">
+            <a:extLst>
+              <a:ext uri="{FF2B5EF4-FFF2-40B4-BE49-F238E27FC236}">
+                <a16:creationId xmlns:a16="http://schemas.microsoft.com/office/drawing/2014/main" id="{F4B92637-3992-4937-D1C7-5911BEF6AA46}"/>
+              </a:ext>
+            </a:extLst>
+          </p:cNvPr>
           <p:cNvSpPr>
             <a:spLocks noGrp="1"/>
           </p:cNvSpPr>
           <p:nvPr>
-            <p:ph type="sldNum" idx="6"/>
+            <p:ph type="sldNum" idx="2"/>
           </p:nvPr>
         </p:nvSpPr>
-        <p:spPr>
-          <a:xfrm>
-            <a:off x="7227360" y="5165280"/>
-            <a:ext cx="2347920" cy="390240"/>
-          </a:xfrm>
-          <a:prstGeom prst="rect">
-            <a:avLst/>
-          </a:prstGeom>
-          <a:noFill/>
-          <a:ln w="0">
-            <a:noFill/>
-          </a:ln>
-        </p:spPr>
-        <p:txBody>
-          <a:bodyPr lIns="0" tIns="0" rIns="0" bIns="0" anchor="t">
-            <a:noAutofit/>
-          </a:bodyPr>
-          <a:lstStyle>
-            <a:lvl1pPr algn="r">
-              <a:lnSpc>
-                <a:spcPct val="100000"/>
-              </a:lnSpc>
-              <a:buNone/>
-              <a:tabLst>
-                <a:tab pos="0" algn="l"/>
-              </a:tabLst>
-              <a:defRPr lang="es-ES" sz="1400" b="0" strike="noStrike" spc="-1">
-                <a:solidFill>
-                  <a:srgbClr val="000000"/>
-                </a:solidFill>
-                <a:latin typeface="Times New Roman"/>
-                <a:ea typeface="Times New Roman"/>
-              </a:defRPr>
-            </a:lvl1pPr>
-          </a:lstStyle>
-          <a:p>
-            <a:pPr algn="r">
-              <a:lnSpc>
-                <a:spcPct val="100000"/>
-              </a:lnSpc>
-              <a:buNone/>
-              <a:tabLst>
-                <a:tab pos="0" algn="l"/>
-              </a:tabLst>
-            </a:pPr>
-            <a:fld id="{6D0060A3-8A5B-4F84-9F76-C245384F212D}" type="slidenum">
-              <a:rPr lang="es-ES" sz="1400" b="0" strike="noStrike" spc="-1" smtClean="0">
-                <a:solidFill>
-                  <a:srgbClr val="000000"/>
-                </a:solidFill>
-                <a:latin typeface="Times New Roman"/>
-                <a:ea typeface="Times New Roman"/>
-              </a:rPr>
+        <p:spPr/>
+        <p:txBody>
+          <a:bodyPr/>
+          <a:lstStyle/>
+          <a:p>
+            <a:fld id="{B99B1A2D-D4B6-4047-AD69-D754256AF902}" type="slidenum">
+              <a:rPr lang="en-MX" smtClean="0"/>
               <a:t>3</a:t>
             </a:fld>
-            <a:r>
-              <a:rPr lang="es-ES" sz="1400" b="0" strike="noStrike" spc="-1" dirty="0">
-                <a:solidFill>
-                  <a:srgbClr val="000000"/>
-                </a:solidFill>
-                <a:latin typeface="Times New Roman"/>
-                <a:ea typeface="Times New Roman"/>
-              </a:rPr>
-              <a:t>/16</a:t>
-            </a:r>
-            <a:endParaRPr lang="es-MX" sz="1400" b="0" strike="noStrike" spc="-1" dirty="0">
-              <a:latin typeface="Times New Roman"/>
-            </a:endParaRPr>
+            <a:endParaRPr lang="en-MX"/>
           </a:p>
         </p:txBody>
       </p:sp>
@@ -7959,82 +9031,30 @@
       </p:sp>
       <p:sp>
         <p:nvSpPr>
-          <p:cNvPr id="74" name="PlaceHolder 1"/>
+          <p:cNvPr id="2" name="Slide Number Placeholder 1">
+            <a:extLst>
+              <a:ext uri="{FF2B5EF4-FFF2-40B4-BE49-F238E27FC236}">
+                <a16:creationId xmlns:a16="http://schemas.microsoft.com/office/drawing/2014/main" id="{615AABF6-C426-A1C7-90F0-25F6484F8C98}"/>
+              </a:ext>
+            </a:extLst>
+          </p:cNvPr>
           <p:cNvSpPr>
             <a:spLocks noGrp="1"/>
           </p:cNvSpPr>
           <p:nvPr>
-            <p:ph type="sldNum" idx="8"/>
+            <p:ph type="sldNum" idx="2"/>
           </p:nvPr>
         </p:nvSpPr>
-        <p:spPr>
-          <a:xfrm>
-            <a:off x="7227360" y="5165280"/>
-            <a:ext cx="2347920" cy="390240"/>
-          </a:xfrm>
-          <a:prstGeom prst="rect">
-            <a:avLst/>
-          </a:prstGeom>
-          <a:noFill/>
-          <a:ln w="0">
-            <a:noFill/>
-          </a:ln>
-        </p:spPr>
-        <p:txBody>
-          <a:bodyPr lIns="0" tIns="0" rIns="0" bIns="0" anchor="t">
-            <a:noAutofit/>
-          </a:bodyPr>
-          <a:lstStyle>
-            <a:lvl1pPr algn="r">
-              <a:lnSpc>
-                <a:spcPct val="100000"/>
-              </a:lnSpc>
-              <a:buNone/>
-              <a:tabLst>
-                <a:tab pos="0" algn="l"/>
-              </a:tabLst>
-              <a:defRPr lang="es-ES" sz="1400" b="0" strike="noStrike" spc="-1">
-                <a:solidFill>
-                  <a:srgbClr val="000000"/>
-                </a:solidFill>
-                <a:latin typeface="Times New Roman"/>
-                <a:ea typeface="Times New Roman"/>
-              </a:defRPr>
-            </a:lvl1pPr>
-          </a:lstStyle>
-          <a:p>
-            <a:pPr algn="r">
-              <a:lnSpc>
-                <a:spcPct val="100000"/>
-              </a:lnSpc>
-              <a:buNone/>
-              <a:tabLst>
-                <a:tab pos="0" algn="l"/>
-              </a:tabLst>
-            </a:pPr>
-            <a:fld id="{8424212C-5A70-43C1-B3B7-0124794E4E62}" type="slidenum">
-              <a:rPr lang="es-ES" sz="1400" b="0" strike="noStrike" spc="-1" smtClean="0">
-                <a:solidFill>
-                  <a:srgbClr val="000000"/>
-                </a:solidFill>
-                <a:latin typeface="Times New Roman"/>
-                <a:ea typeface="Times New Roman"/>
-              </a:rPr>
+        <p:spPr/>
+        <p:txBody>
+          <a:bodyPr/>
+          <a:lstStyle/>
+          <a:p>
+            <a:fld id="{B99B1A2D-D4B6-4047-AD69-D754256AF902}" type="slidenum">
+              <a:rPr lang="en-MX" smtClean="0"/>
               <a:t>4</a:t>
             </a:fld>
-            <a:r>
-              <a:rPr lang="es-ES" sz="1400" b="0" strike="noStrike" spc="-1" dirty="0">
-                <a:solidFill>
-                  <a:srgbClr val="000000"/>
-                </a:solidFill>
-                <a:latin typeface="Times New Roman"/>
-                <a:ea typeface="Times New Roman"/>
-              </a:rPr>
-              <a:t>/16</a:t>
-            </a:r>
-            <a:endParaRPr lang="es-MX" sz="1400" b="0" strike="noStrike" spc="-1" dirty="0">
-              <a:latin typeface="Times New Roman"/>
-            </a:endParaRPr>
+            <a:endParaRPr lang="en-MX"/>
           </a:p>
         </p:txBody>
       </p:sp>
@@ -8163,7 +9183,7 @@
                 <a:latin typeface="Calibri"/>
                 <a:ea typeface="Calibri"/>
               </a:rPr>
-              <a:t>Hipótesis y Justificación</a:t>
+              <a:t>Hipótesis </a:t>
             </a:r>
             <a:endParaRPr lang="es-MX" sz="2600" b="0" strike="noStrike" spc="-1" dirty="0">
               <a:latin typeface="Arial"/>
@@ -8180,7 +9200,7 @@
         <p:spPr>
           <a:xfrm>
             <a:off x="1040186" y="1186160"/>
-            <a:ext cx="3045431" cy="3693319"/>
+            <a:ext cx="8549087" cy="1477328"/>
           </a:xfrm>
           <a:prstGeom prst="rect">
             <a:avLst/>
@@ -8413,312 +9433,30 @@
       </p:sp>
       <p:sp>
         <p:nvSpPr>
-          <p:cNvPr id="79" name="PlaceHolder 1"/>
+          <p:cNvPr id="3" name="Slide Number Placeholder 2">
+            <a:extLst>
+              <a:ext uri="{FF2B5EF4-FFF2-40B4-BE49-F238E27FC236}">
+                <a16:creationId xmlns:a16="http://schemas.microsoft.com/office/drawing/2014/main" id="{C38787F3-66BC-2B81-2134-2EDE74FBC347}"/>
+              </a:ext>
+            </a:extLst>
+          </p:cNvPr>
           <p:cNvSpPr>
             <a:spLocks noGrp="1"/>
           </p:cNvSpPr>
           <p:nvPr>
-            <p:ph type="sldNum" idx="9"/>
+            <p:ph type="sldNum" idx="2"/>
           </p:nvPr>
         </p:nvSpPr>
-        <p:spPr>
-          <a:xfrm>
-            <a:off x="7227360" y="5165280"/>
-            <a:ext cx="2347920" cy="390240"/>
-          </a:xfrm>
-          <a:prstGeom prst="rect">
-            <a:avLst/>
-          </a:prstGeom>
-          <a:noFill/>
-          <a:ln w="0">
-            <a:noFill/>
-          </a:ln>
-        </p:spPr>
-        <p:txBody>
-          <a:bodyPr lIns="0" tIns="0" rIns="0" bIns="0" anchor="t">
-            <a:noAutofit/>
-          </a:bodyPr>
-          <a:lstStyle>
-            <a:lvl1pPr algn="r">
-              <a:lnSpc>
-                <a:spcPct val="100000"/>
-              </a:lnSpc>
-              <a:buNone/>
-              <a:tabLst>
-                <a:tab pos="0" algn="l"/>
-              </a:tabLst>
-              <a:defRPr lang="es-ES" sz="1400" b="0" strike="noStrike" spc="-1">
-                <a:solidFill>
-                  <a:srgbClr val="000000"/>
-                </a:solidFill>
-                <a:latin typeface="Times New Roman"/>
-                <a:ea typeface="Times New Roman"/>
-              </a:defRPr>
-            </a:lvl1pPr>
-          </a:lstStyle>
-          <a:p>
-            <a:pPr algn="r">
-              <a:lnSpc>
-                <a:spcPct val="100000"/>
-              </a:lnSpc>
-              <a:buNone/>
-              <a:tabLst>
-                <a:tab pos="0" algn="l"/>
-              </a:tabLst>
-            </a:pPr>
-            <a:fld id="{45E84D77-4C16-4FC3-8370-FC3F9AF9C282}" type="slidenum">
-              <a:rPr lang="es-ES" sz="1400" b="0" strike="noStrike" spc="-1">
-                <a:solidFill>
-                  <a:srgbClr val="000000"/>
-                </a:solidFill>
-                <a:latin typeface="Times New Roman"/>
-                <a:ea typeface="Times New Roman"/>
-              </a:rPr>
+        <p:spPr/>
+        <p:txBody>
+          <a:bodyPr/>
+          <a:lstStyle/>
+          <a:p>
+            <a:fld id="{B99B1A2D-D4B6-4047-AD69-D754256AF902}" type="slidenum">
+              <a:rPr lang="en-MX" smtClean="0"/>
               <a:t>5</a:t>
             </a:fld>
-            <a:r>
-              <a:rPr lang="es-ES" sz="1400" b="0" strike="noStrike" spc="-1">
-                <a:solidFill>
-                  <a:srgbClr val="000000"/>
-                </a:solidFill>
-                <a:latin typeface="Times New Roman"/>
-                <a:ea typeface="Times New Roman"/>
-              </a:rPr>
-              <a:t>/18</a:t>
-            </a:r>
-            <a:endParaRPr lang="es-MX" sz="1400" b="0" strike="noStrike" spc="-1">
-              <a:latin typeface="Times New Roman"/>
-            </a:endParaRPr>
-          </a:p>
-        </p:txBody>
-      </p:sp>
-      <p:sp>
-        <p:nvSpPr>
-          <p:cNvPr id="2" name="TextBox 1">
-            <a:extLst>
-              <a:ext uri="{FF2B5EF4-FFF2-40B4-BE49-F238E27FC236}">
-                <a16:creationId xmlns:a16="http://schemas.microsoft.com/office/drawing/2014/main" id="{612159EB-9DB8-91AE-F98F-B104CE082F0B}"/>
-              </a:ext>
-            </a:extLst>
-          </p:cNvPr>
-          <p:cNvSpPr txBox="1"/>
-          <p:nvPr/>
-        </p:nvSpPr>
-        <p:spPr>
-          <a:xfrm>
-            <a:off x="5720433" y="1484280"/>
-            <a:ext cx="3320006" cy="2862322"/>
-          </a:xfrm>
-          <a:prstGeom prst="rect">
-            <a:avLst/>
-          </a:prstGeom>
-          <a:noFill/>
-        </p:spPr>
-        <p:txBody>
-          <a:bodyPr wrap="square" rtlCol="0">
-            <a:spAutoFit/>
-          </a:bodyPr>
-          <a:lstStyle/>
-          <a:p>
-            <a:pPr algn="just">
-              <a:buClr>
-                <a:srgbClr val="000000"/>
-              </a:buClr>
-            </a:pPr>
-            <a:r>
-              <a:rPr lang="en-US" dirty="0"/>
-              <a:t>La </a:t>
-            </a:r>
-            <a:r>
-              <a:rPr lang="en-US" dirty="0" err="1"/>
-              <a:t>combinación</a:t>
-            </a:r>
-            <a:r>
-              <a:rPr lang="en-US" dirty="0"/>
-              <a:t> de </a:t>
-            </a:r>
-            <a:r>
-              <a:rPr lang="en-US" dirty="0" err="1"/>
-              <a:t>Aprendizaje</a:t>
-            </a:r>
-            <a:r>
-              <a:rPr lang="en-US" dirty="0"/>
-              <a:t> Incremental y </a:t>
-            </a:r>
-            <a:r>
-              <a:rPr lang="en-US" dirty="0" err="1"/>
-              <a:t>TinyML</a:t>
-            </a:r>
-            <a:r>
-              <a:rPr lang="en-US" dirty="0"/>
-              <a:t> </a:t>
-            </a:r>
-            <a:r>
-              <a:rPr lang="en-US" dirty="0" err="1"/>
-              <a:t>permite</a:t>
-            </a:r>
-            <a:r>
-              <a:rPr lang="en-US" dirty="0"/>
-              <a:t> </a:t>
-            </a:r>
-            <a:r>
-              <a:rPr lang="en-US" dirty="0" err="1"/>
-              <a:t>crear</a:t>
-            </a:r>
-            <a:r>
-              <a:rPr lang="en-US" dirty="0"/>
-              <a:t> </a:t>
-            </a:r>
-            <a:r>
-              <a:rPr lang="en-US" dirty="0" err="1"/>
-              <a:t>modelos</a:t>
-            </a:r>
-            <a:r>
-              <a:rPr lang="en-US" dirty="0"/>
-              <a:t> </a:t>
-            </a:r>
-            <a:r>
-              <a:rPr lang="en-US" dirty="0" err="1"/>
-              <a:t>que</a:t>
-            </a:r>
-            <a:r>
-              <a:rPr lang="en-US" dirty="0"/>
-              <a:t> </a:t>
-            </a:r>
-            <a:r>
-              <a:rPr lang="en-US" dirty="0" err="1"/>
-              <a:t>aprenden</a:t>
-            </a:r>
-            <a:r>
-              <a:rPr lang="en-US" dirty="0"/>
-              <a:t>, se </a:t>
-            </a:r>
-            <a:r>
-              <a:rPr lang="en-US" dirty="0" err="1"/>
-              <a:t>adaptan</a:t>
-            </a:r>
-            <a:r>
-              <a:rPr lang="en-US" dirty="0"/>
-              <a:t> y </a:t>
-            </a:r>
-            <a:r>
-              <a:rPr lang="en-US" dirty="0" err="1"/>
-              <a:t>mantienen</a:t>
-            </a:r>
-            <a:r>
-              <a:rPr lang="en-US" dirty="0"/>
-              <a:t> </a:t>
-            </a:r>
-            <a:r>
-              <a:rPr lang="en-US" dirty="0" err="1"/>
-              <a:t>su</a:t>
-            </a:r>
-            <a:r>
-              <a:rPr lang="en-US" dirty="0"/>
-              <a:t> memoria </a:t>
-            </a:r>
-            <a:r>
-              <a:rPr lang="en-US" dirty="0" err="1"/>
-              <a:t>directamente</a:t>
-            </a:r>
-            <a:r>
-              <a:rPr lang="en-US" dirty="0"/>
-              <a:t> </a:t>
-            </a:r>
-            <a:r>
-              <a:rPr lang="en-US" dirty="0" err="1"/>
-              <a:t>en</a:t>
-            </a:r>
-            <a:r>
-              <a:rPr lang="en-US" dirty="0"/>
-              <a:t> </a:t>
-            </a:r>
-            <a:r>
-              <a:rPr lang="en-US" dirty="0" err="1"/>
-              <a:t>dispositivos</a:t>
-            </a:r>
-            <a:r>
-              <a:rPr lang="en-US" dirty="0"/>
-              <a:t> con </a:t>
-            </a:r>
-            <a:r>
-              <a:rPr lang="en-US" dirty="0" err="1"/>
-              <a:t>recursos</a:t>
-            </a:r>
-            <a:r>
-              <a:rPr lang="en-US" dirty="0"/>
-              <a:t> </a:t>
-            </a:r>
-            <a:r>
-              <a:rPr lang="en-US" dirty="0" err="1"/>
-              <a:t>limitados</a:t>
-            </a:r>
-            <a:r>
-              <a:rPr lang="en-US" dirty="0"/>
-              <a:t>. Esto </a:t>
-            </a:r>
-            <a:r>
-              <a:rPr lang="en-US" dirty="0" err="1"/>
-              <a:t>mejora</a:t>
-            </a:r>
-            <a:r>
-              <a:rPr lang="en-US" dirty="0"/>
-              <a:t> </a:t>
-            </a:r>
-            <a:r>
-              <a:rPr lang="en-US" dirty="0" err="1"/>
-              <a:t>privacidad</a:t>
-            </a:r>
-            <a:r>
-              <a:rPr lang="en-US" dirty="0"/>
-              <a:t>, </a:t>
-            </a:r>
-            <a:r>
-              <a:rPr lang="en-US" dirty="0" err="1"/>
-              <a:t>eficiencia</a:t>
-            </a:r>
-            <a:r>
-              <a:rPr lang="en-US" dirty="0"/>
-              <a:t> y </a:t>
-            </a:r>
-            <a:r>
-              <a:rPr lang="en-US" dirty="0" err="1"/>
-              <a:t>abre</a:t>
-            </a:r>
-            <a:r>
-              <a:rPr lang="en-US" dirty="0"/>
-              <a:t> </a:t>
-            </a:r>
-            <a:r>
-              <a:rPr lang="en-US" dirty="0" err="1"/>
-              <a:t>nuevas</a:t>
-            </a:r>
-            <a:r>
-              <a:rPr lang="en-US" dirty="0"/>
-              <a:t> </a:t>
-            </a:r>
-            <a:r>
-              <a:rPr lang="en-US" dirty="0" err="1"/>
-              <a:t>posibilidades</a:t>
-            </a:r>
-            <a:r>
-              <a:rPr lang="en-US" dirty="0"/>
-              <a:t> para IA </a:t>
-            </a:r>
-            <a:r>
-              <a:rPr lang="en-US" dirty="0" err="1"/>
-              <a:t>embebida</a:t>
-            </a:r>
-            <a:r>
-              <a:rPr lang="es-ES" spc="-1" dirty="0">
-                <a:solidFill>
-                  <a:srgbClr val="000000"/>
-                </a:solidFill>
-                <a:ea typeface="Arial"/>
-              </a:rPr>
-              <a:t>.</a:t>
-            </a:r>
-            <a:endParaRPr lang="es-MX" spc="-1" dirty="0"/>
+            <a:endParaRPr lang="en-MX"/>
           </a:p>
         </p:txBody>
       </p:sp>
@@ -8731,6 +9469,427 @@
 </file>
 
 <file path=ppt/slides/slide6.xml><?xml version="1.0" encoding="utf-8"?>
+<p:sld xmlns:a="http://schemas.openxmlformats.org/drawingml/2006/main" xmlns:r="http://schemas.openxmlformats.org/officeDocument/2006/relationships" xmlns:p="http://schemas.openxmlformats.org/presentationml/2006/main">
+  <p:cSld>
+    <p:spTree>
+      <p:nvGrpSpPr>
+        <p:cNvPr id="1" name="">
+          <a:extLst>
+            <a:ext uri="{FF2B5EF4-FFF2-40B4-BE49-F238E27FC236}">
+              <a16:creationId xmlns:a16="http://schemas.microsoft.com/office/drawing/2014/main" id="{4E6BDF11-9DC5-9A11-6C04-BA942D0A6E9F}"/>
+            </a:ext>
+          </a:extLst>
+        </p:cNvPr>
+        <p:cNvGrpSpPr/>
+        <p:nvPr/>
+      </p:nvGrpSpPr>
+      <p:grpSpPr>
+        <a:xfrm>
+          <a:off x="0" y="0"/>
+          <a:ext cx="0" cy="0"/>
+          <a:chOff x="0" y="0"/>
+          <a:chExt cx="0" cy="0"/>
+        </a:xfrm>
+      </p:grpSpPr>
+      <p:pic>
+        <p:nvPicPr>
+          <p:cNvPr id="75" name="Google Shape;149;p6">
+            <a:extLst>
+              <a:ext uri="{FF2B5EF4-FFF2-40B4-BE49-F238E27FC236}">
+                <a16:creationId xmlns:a16="http://schemas.microsoft.com/office/drawing/2014/main" id="{64B543F3-B634-8757-03EE-7389352DB174}"/>
+              </a:ext>
+            </a:extLst>
+          </p:cNvPr>
+          <p:cNvPicPr/>
+          <p:nvPr/>
+        </p:nvPicPr>
+        <p:blipFill>
+          <a:blip r:embed="rId2"/>
+          <a:stretch/>
+        </p:blipFill>
+        <p:spPr>
+          <a:xfrm>
+            <a:off x="360" y="4984200"/>
+            <a:ext cx="10079280" cy="685440"/>
+          </a:xfrm>
+          <a:prstGeom prst="rect">
+            <a:avLst/>
+          </a:prstGeom>
+          <a:ln w="0">
+            <a:noFill/>
+          </a:ln>
+        </p:spPr>
+      </p:pic>
+      <p:pic>
+        <p:nvPicPr>
+          <p:cNvPr id="76" name="Google Shape;150;p6">
+            <a:extLst>
+              <a:ext uri="{FF2B5EF4-FFF2-40B4-BE49-F238E27FC236}">
+                <a16:creationId xmlns:a16="http://schemas.microsoft.com/office/drawing/2014/main" id="{9BC61705-CE66-A1AC-1806-4B8335D4FCE8}"/>
+              </a:ext>
+            </a:extLst>
+          </p:cNvPr>
+          <p:cNvPicPr/>
+          <p:nvPr/>
+        </p:nvPicPr>
+        <p:blipFill>
+          <a:blip r:embed="rId3"/>
+          <a:stretch/>
+        </p:blipFill>
+        <p:spPr>
+          <a:xfrm>
+            <a:off x="360" y="0"/>
+            <a:ext cx="1598400" cy="1484280"/>
+          </a:xfrm>
+          <a:prstGeom prst="rect">
+            <a:avLst/>
+          </a:prstGeom>
+          <a:ln w="0">
+            <a:noFill/>
+          </a:ln>
+        </p:spPr>
+      </p:pic>
+      <p:sp>
+        <p:nvSpPr>
+          <p:cNvPr id="77" name="Google Shape;151;p6">
+            <a:extLst>
+              <a:ext uri="{FF2B5EF4-FFF2-40B4-BE49-F238E27FC236}">
+                <a16:creationId xmlns:a16="http://schemas.microsoft.com/office/drawing/2014/main" id="{D7FAB7F9-D024-2F52-BBCD-FF5E90395544}"/>
+              </a:ext>
+            </a:extLst>
+          </p:cNvPr>
+          <p:cNvSpPr/>
+          <p:nvPr/>
+        </p:nvSpPr>
+        <p:spPr>
+          <a:xfrm>
+            <a:off x="1986120" y="402840"/>
+            <a:ext cx="6107760" cy="678600"/>
+          </a:xfrm>
+          <a:prstGeom prst="rect">
+            <a:avLst/>
+          </a:prstGeom>
+          <a:noFill/>
+          <a:ln w="0">
+            <a:noFill/>
+          </a:ln>
+        </p:spPr>
+        <p:style>
+          <a:lnRef idx="0">
+            <a:scrgbClr r="0" g="0" b="0"/>
+          </a:lnRef>
+          <a:fillRef idx="0">
+            <a:scrgbClr r="0" g="0" b="0"/>
+          </a:fillRef>
+          <a:effectRef idx="0">
+            <a:scrgbClr r="0" g="0" b="0"/>
+          </a:effectRef>
+          <a:fontRef idx="minor"/>
+        </p:style>
+        <p:txBody>
+          <a:bodyPr anchor="ctr">
+            <a:normAutofit/>
+          </a:bodyPr>
+          <a:lstStyle/>
+          <a:p>
+            <a:pPr algn="ctr">
+              <a:lnSpc>
+                <a:spcPct val="100000"/>
+              </a:lnSpc>
+              <a:buNone/>
+              <a:tabLst>
+                <a:tab pos="0" algn="l"/>
+              </a:tabLst>
+            </a:pPr>
+            <a:r>
+              <a:rPr lang="es-ES" sz="2600" b="1" strike="noStrike" spc="-1" dirty="0">
+                <a:solidFill>
+                  <a:srgbClr val="000000"/>
+                </a:solidFill>
+                <a:latin typeface="Calibri"/>
+                <a:ea typeface="Calibri"/>
+              </a:rPr>
+              <a:t>Justificación</a:t>
+            </a:r>
+            <a:endParaRPr lang="es-MX" sz="2600" b="0" strike="noStrike" spc="-1" dirty="0">
+              <a:latin typeface="Arial"/>
+            </a:endParaRPr>
+          </a:p>
+        </p:txBody>
+      </p:sp>
+      <p:sp>
+        <p:nvSpPr>
+          <p:cNvPr id="2" name="TextBox 1">
+            <a:extLst>
+              <a:ext uri="{FF2B5EF4-FFF2-40B4-BE49-F238E27FC236}">
+                <a16:creationId xmlns:a16="http://schemas.microsoft.com/office/drawing/2014/main" id="{4646FE8E-2B4B-384E-FF4A-06562E82F192}"/>
+              </a:ext>
+            </a:extLst>
+          </p:cNvPr>
+          <p:cNvSpPr txBox="1"/>
+          <p:nvPr/>
+        </p:nvSpPr>
+        <p:spPr>
+          <a:xfrm>
+            <a:off x="1052518" y="1433746"/>
+            <a:ext cx="7974964" cy="1200329"/>
+          </a:xfrm>
+          <a:prstGeom prst="rect">
+            <a:avLst/>
+          </a:prstGeom>
+          <a:noFill/>
+        </p:spPr>
+        <p:txBody>
+          <a:bodyPr wrap="square" rtlCol="0">
+            <a:spAutoFit/>
+          </a:bodyPr>
+          <a:lstStyle/>
+          <a:p>
+            <a:pPr algn="just">
+              <a:buClr>
+                <a:srgbClr val="000000"/>
+              </a:buClr>
+            </a:pPr>
+            <a:r>
+              <a:rPr lang="en-US" dirty="0"/>
+              <a:t>La </a:t>
+            </a:r>
+            <a:r>
+              <a:rPr lang="en-US" dirty="0" err="1"/>
+              <a:t>combinación</a:t>
+            </a:r>
+            <a:r>
+              <a:rPr lang="en-US" dirty="0"/>
+              <a:t> de </a:t>
+            </a:r>
+            <a:r>
+              <a:rPr lang="en-US" dirty="0" err="1"/>
+              <a:t>Aprendizaje</a:t>
+            </a:r>
+            <a:r>
+              <a:rPr lang="en-US" dirty="0"/>
+              <a:t> Incremental y </a:t>
+            </a:r>
+            <a:r>
+              <a:rPr lang="en-US" dirty="0" err="1"/>
+              <a:t>TinyML</a:t>
+            </a:r>
+            <a:r>
+              <a:rPr lang="en-US" dirty="0"/>
+              <a:t> </a:t>
+            </a:r>
+            <a:r>
+              <a:rPr lang="en-US" dirty="0" err="1"/>
+              <a:t>permite</a:t>
+            </a:r>
+            <a:r>
+              <a:rPr lang="en-US" dirty="0"/>
+              <a:t> </a:t>
+            </a:r>
+            <a:r>
+              <a:rPr lang="en-US" dirty="0" err="1"/>
+              <a:t>crear</a:t>
+            </a:r>
+            <a:r>
+              <a:rPr lang="en-US" dirty="0"/>
+              <a:t> </a:t>
+            </a:r>
+            <a:r>
+              <a:rPr lang="en-US" dirty="0" err="1"/>
+              <a:t>modelos</a:t>
+            </a:r>
+            <a:r>
+              <a:rPr lang="en-US" dirty="0"/>
+              <a:t> </a:t>
+            </a:r>
+            <a:r>
+              <a:rPr lang="en-US" dirty="0" err="1"/>
+              <a:t>que</a:t>
+            </a:r>
+            <a:r>
+              <a:rPr lang="en-US" dirty="0"/>
+              <a:t> </a:t>
+            </a:r>
+            <a:r>
+              <a:rPr lang="en-US" dirty="0" err="1"/>
+              <a:t>aprenden</a:t>
+            </a:r>
+            <a:r>
+              <a:rPr lang="en-US" dirty="0"/>
+              <a:t>, se </a:t>
+            </a:r>
+            <a:r>
+              <a:rPr lang="en-US" dirty="0" err="1"/>
+              <a:t>adaptan</a:t>
+            </a:r>
+            <a:r>
+              <a:rPr lang="en-US" dirty="0"/>
+              <a:t> y </a:t>
+            </a:r>
+            <a:r>
+              <a:rPr lang="en-US" dirty="0" err="1"/>
+              <a:t>mantienen</a:t>
+            </a:r>
+            <a:r>
+              <a:rPr lang="en-US" dirty="0"/>
+              <a:t> </a:t>
+            </a:r>
+            <a:r>
+              <a:rPr lang="en-US" dirty="0" err="1"/>
+              <a:t>su</a:t>
+            </a:r>
+            <a:r>
+              <a:rPr lang="en-US" dirty="0"/>
+              <a:t> memoria </a:t>
+            </a:r>
+            <a:r>
+              <a:rPr lang="en-US" dirty="0" err="1"/>
+              <a:t>directamente</a:t>
+            </a:r>
+            <a:r>
+              <a:rPr lang="en-US" dirty="0"/>
+              <a:t> </a:t>
+            </a:r>
+            <a:r>
+              <a:rPr lang="en-US" dirty="0" err="1"/>
+              <a:t>en</a:t>
+            </a:r>
+            <a:r>
+              <a:rPr lang="en-US" dirty="0"/>
+              <a:t> </a:t>
+            </a:r>
+            <a:r>
+              <a:rPr lang="en-US" dirty="0" err="1"/>
+              <a:t>dispositivos</a:t>
+            </a:r>
+            <a:r>
+              <a:rPr lang="en-US" dirty="0"/>
+              <a:t> con </a:t>
+            </a:r>
+            <a:r>
+              <a:rPr lang="en-US" dirty="0" err="1"/>
+              <a:t>recursos</a:t>
+            </a:r>
+            <a:r>
+              <a:rPr lang="en-US" dirty="0"/>
+              <a:t> </a:t>
+            </a:r>
+            <a:r>
+              <a:rPr lang="en-US" dirty="0" err="1"/>
+              <a:t>limitados</a:t>
+            </a:r>
+            <a:r>
+              <a:rPr lang="en-US" dirty="0"/>
+              <a:t>. Esto </a:t>
+            </a:r>
+            <a:r>
+              <a:rPr lang="en-US" dirty="0" err="1"/>
+              <a:t>mejora</a:t>
+            </a:r>
+            <a:r>
+              <a:rPr lang="en-US" dirty="0"/>
+              <a:t> </a:t>
+            </a:r>
+            <a:r>
+              <a:rPr lang="en-US" dirty="0" err="1"/>
+              <a:t>privacidad</a:t>
+            </a:r>
+            <a:r>
+              <a:rPr lang="en-US" dirty="0"/>
+              <a:t>, </a:t>
+            </a:r>
+            <a:r>
+              <a:rPr lang="en-US" dirty="0" err="1"/>
+              <a:t>eficiencia</a:t>
+            </a:r>
+            <a:r>
+              <a:rPr lang="en-US" dirty="0"/>
+              <a:t> y </a:t>
+            </a:r>
+            <a:r>
+              <a:rPr lang="en-US" dirty="0" err="1"/>
+              <a:t>abre</a:t>
+            </a:r>
+            <a:r>
+              <a:rPr lang="en-US" dirty="0"/>
+              <a:t> </a:t>
+            </a:r>
+            <a:r>
+              <a:rPr lang="en-US" dirty="0" err="1"/>
+              <a:t>nuevas</a:t>
+            </a:r>
+            <a:r>
+              <a:rPr lang="en-US" dirty="0"/>
+              <a:t> </a:t>
+            </a:r>
+            <a:r>
+              <a:rPr lang="en-US" dirty="0" err="1"/>
+              <a:t>posibilidades</a:t>
+            </a:r>
+            <a:r>
+              <a:rPr lang="en-US" dirty="0"/>
+              <a:t> para IA </a:t>
+            </a:r>
+            <a:r>
+              <a:rPr lang="en-US" dirty="0" err="1"/>
+              <a:t>embebida</a:t>
+            </a:r>
+            <a:r>
+              <a:rPr lang="es-ES" spc="-1" dirty="0">
+                <a:solidFill>
+                  <a:srgbClr val="000000"/>
+                </a:solidFill>
+                <a:ea typeface="Arial"/>
+              </a:rPr>
+              <a:t>.</a:t>
+            </a:r>
+            <a:endParaRPr lang="es-MX" spc="-1" dirty="0"/>
+          </a:p>
+        </p:txBody>
+      </p:sp>
+      <p:sp>
+        <p:nvSpPr>
+          <p:cNvPr id="3" name="Slide Number Placeholder 2">
+            <a:extLst>
+              <a:ext uri="{FF2B5EF4-FFF2-40B4-BE49-F238E27FC236}">
+                <a16:creationId xmlns:a16="http://schemas.microsoft.com/office/drawing/2014/main" id="{873B55DD-5F39-2955-E7EA-2679C3B47314}"/>
+              </a:ext>
+            </a:extLst>
+          </p:cNvPr>
+          <p:cNvSpPr>
+            <a:spLocks noGrp="1"/>
+          </p:cNvSpPr>
+          <p:nvPr>
+            <p:ph type="sldNum" idx="2"/>
+          </p:nvPr>
+        </p:nvSpPr>
+        <p:spPr/>
+        <p:txBody>
+          <a:bodyPr/>
+          <a:lstStyle/>
+          <a:p>
+            <a:fld id="{B99B1A2D-D4B6-4047-AD69-D754256AF902}" type="slidenum">
+              <a:rPr lang="en-MX" smtClean="0"/>
+              <a:t>6</a:t>
+            </a:fld>
+            <a:endParaRPr lang="en-MX"/>
+          </a:p>
+        </p:txBody>
+      </p:sp>
+    </p:spTree>
+    <p:extLst>
+      <p:ext uri="{BB962C8B-B14F-4D97-AF65-F5344CB8AC3E}">
+        <p14:creationId xmlns:p14="http://schemas.microsoft.com/office/powerpoint/2010/main" val="564957908"/>
+      </p:ext>
+    </p:extLst>
+  </p:cSld>
+  <p:clrMapOvr>
+    <a:masterClrMapping/>
+  </p:clrMapOvr>
+</p:sld>
+</file>
+
+<file path=ppt/slides/slide7.xml><?xml version="1.0" encoding="utf-8"?>
 <p:sld xmlns:a="http://schemas.openxmlformats.org/drawingml/2006/main" xmlns:r="http://schemas.openxmlformats.org/officeDocument/2006/relationships" xmlns:p="http://schemas.openxmlformats.org/presentationml/2006/main">
   <p:cSld>
     <p:spTree>
@@ -8886,7 +10045,7 @@
               </a:tabLst>
             </a:pPr>
             <a:r>
-              <a:rPr lang="es-ES" sz="2600" b="1" strike="noStrike" spc="-1">
+              <a:rPr lang="es-ES" sz="2600" b="1" strike="noStrike" spc="-1" dirty="0">
                 <a:solidFill>
                   <a:srgbClr val="000000"/>
                 </a:solidFill>
@@ -8895,7 +10054,7 @@
               </a:rPr>
               <a:t>Redes Neuronales de Perceptrón Multicapa</a:t>
             </a:r>
-            <a:endParaRPr lang="es-MX" sz="2600" b="0" strike="noStrike" spc="-1">
+            <a:endParaRPr lang="es-MX" sz="2600" b="0" strike="noStrike" spc="-1" dirty="0">
               <a:solidFill>
                 <a:srgbClr val="000000"/>
               </a:solidFill>
@@ -8929,72 +10088,30 @@
       </p:pic>
       <p:sp>
         <p:nvSpPr>
-          <p:cNvPr id="103" name="PlaceHolder 3"/>
+          <p:cNvPr id="2" name="Slide Number Placeholder 1">
+            <a:extLst>
+              <a:ext uri="{FF2B5EF4-FFF2-40B4-BE49-F238E27FC236}">
+                <a16:creationId xmlns:a16="http://schemas.microsoft.com/office/drawing/2014/main" id="{2AAD15A9-BDD6-846A-6B64-156AA433E7AD}"/>
+              </a:ext>
+            </a:extLst>
+          </p:cNvPr>
           <p:cNvSpPr>
             <a:spLocks noGrp="1"/>
           </p:cNvSpPr>
           <p:nvPr>
-            <p:ph type="sldNum" idx="13"/>
+            <p:ph type="sldNum" idx="2"/>
           </p:nvPr>
         </p:nvSpPr>
-        <p:spPr>
-          <a:xfrm>
-            <a:off x="7227360" y="5165280"/>
-            <a:ext cx="2347920" cy="390240"/>
-          </a:xfrm>
-          <a:prstGeom prst="rect">
-            <a:avLst/>
-          </a:prstGeom>
-          <a:noFill/>
-          <a:ln w="0">
-            <a:noFill/>
-          </a:ln>
-        </p:spPr>
-        <p:txBody>
-          <a:bodyPr lIns="0" tIns="0" rIns="0" bIns="0" anchor="t">
-            <a:noAutofit/>
-          </a:bodyPr>
-          <a:lstStyle>
-            <a:lvl1pPr algn="r">
-              <a:lnSpc>
-                <a:spcPct val="100000"/>
-              </a:lnSpc>
-              <a:buNone/>
-              <a:tabLst>
-                <a:tab pos="0" algn="l"/>
-              </a:tabLst>
-              <a:defRPr lang="es-ES" sz="1400" b="0" strike="noStrike" spc="-1">
-                <a:solidFill>
-                  <a:srgbClr val="000000"/>
-                </a:solidFill>
-                <a:latin typeface="Times New Roman"/>
-                <a:ea typeface="Times New Roman"/>
-              </a:defRPr>
-            </a:lvl1pPr>
-          </a:lstStyle>
-          <a:p>
-            <a:pPr algn="r">
-              <a:lnSpc>
-                <a:spcPct val="100000"/>
-              </a:lnSpc>
-              <a:buNone/>
-              <a:tabLst>
-                <a:tab pos="0" algn="l"/>
-              </a:tabLst>
-            </a:pPr>
-            <a:r>
-              <a:rPr lang="es-ES" sz="1400" b="0" strike="noStrike" spc="-1" dirty="0">
-                <a:solidFill>
-                  <a:srgbClr val="000000"/>
-                </a:solidFill>
-                <a:latin typeface="Times New Roman"/>
-                <a:ea typeface="Times New Roman"/>
-              </a:rPr>
-              <a:t>10/16</a:t>
-            </a:r>
-            <a:endParaRPr lang="es-MX" sz="1400" b="0" strike="noStrike" spc="-1" dirty="0">
-              <a:latin typeface="Times New Roman"/>
-            </a:endParaRPr>
+        <p:spPr/>
+        <p:txBody>
+          <a:bodyPr/>
+          <a:lstStyle/>
+          <a:p>
+            <a:fld id="{B99B1A2D-D4B6-4047-AD69-D754256AF902}" type="slidenum">
+              <a:rPr lang="en-MX" smtClean="0"/>
+              <a:t>7</a:t>
+            </a:fld>
+            <a:endParaRPr lang="en-MX"/>
           </a:p>
         </p:txBody>
       </p:sp>
@@ -9006,7 +10123,7 @@
 </p:sld>
 </file>
 
-<file path=ppt/slides/slide7.xml><?xml version="1.0" encoding="utf-8"?>
+<file path=ppt/slides/slide8.xml><?xml version="1.0" encoding="utf-8"?>
 <p:sld xmlns:a="http://schemas.openxmlformats.org/drawingml/2006/main" xmlns:r="http://schemas.openxmlformats.org/officeDocument/2006/relationships" xmlns:p="http://schemas.openxmlformats.org/presentationml/2006/main">
   <p:cSld>
     <p:spTree>
@@ -9150,83 +10267,6 @@
           </a:p>
         </p:txBody>
       </p:sp>
-      <p:sp>
-        <p:nvSpPr>
-          <p:cNvPr id="103" name="PlaceHolder 3">
-            <a:extLst>
-              <a:ext uri="{FF2B5EF4-FFF2-40B4-BE49-F238E27FC236}">
-                <a16:creationId xmlns:a16="http://schemas.microsoft.com/office/drawing/2014/main" id="{8CC3B4B7-95B1-BB52-8B4C-B3689FA35599}"/>
-              </a:ext>
-            </a:extLst>
-          </p:cNvPr>
-          <p:cNvSpPr>
-            <a:spLocks noGrp="1"/>
-          </p:cNvSpPr>
-          <p:nvPr>
-            <p:ph type="sldNum" idx="13"/>
-          </p:nvPr>
-        </p:nvSpPr>
-        <p:spPr>
-          <a:xfrm>
-            <a:off x="7227360" y="5165280"/>
-            <a:ext cx="2347920" cy="390240"/>
-          </a:xfrm>
-          <a:prstGeom prst="rect">
-            <a:avLst/>
-          </a:prstGeom>
-          <a:noFill/>
-          <a:ln w="0">
-            <a:noFill/>
-          </a:ln>
-        </p:spPr>
-        <p:txBody>
-          <a:bodyPr lIns="0" tIns="0" rIns="0" bIns="0" anchor="t">
-            <a:noAutofit/>
-          </a:bodyPr>
-          <a:lstStyle>
-            <a:lvl1pPr algn="r">
-              <a:lnSpc>
-                <a:spcPct val="100000"/>
-              </a:lnSpc>
-              <a:buNone/>
-              <a:tabLst>
-                <a:tab pos="0" algn="l"/>
-              </a:tabLst>
-              <a:defRPr lang="es-ES" sz="1400" b="0" strike="noStrike" spc="-1">
-                <a:solidFill>
-                  <a:srgbClr val="000000"/>
-                </a:solidFill>
-                <a:latin typeface="Times New Roman"/>
-                <a:ea typeface="Times New Roman"/>
-              </a:defRPr>
-            </a:lvl1pPr>
-          </a:lstStyle>
-          <a:p>
-            <a:pPr algn="r">
-              <a:lnSpc>
-                <a:spcPct val="100000"/>
-              </a:lnSpc>
-              <a:buNone/>
-              <a:tabLst>
-                <a:tab pos="0" algn="l"/>
-              </a:tabLst>
-            </a:pPr>
-            <a:r>
-              <a:rPr lang="es-ES" sz="1400" b="0" strike="noStrike" spc="-1" dirty="0">
-                <a:solidFill>
-                  <a:srgbClr val="000000"/>
-                </a:solidFill>
-                <a:latin typeface="Times New Roman"/>
-                <a:ea typeface="Times New Roman"/>
-              </a:rPr>
-              <a:t>10/16</a:t>
-            </a:r>
-            <a:endParaRPr lang="es-MX" sz="1400" b="0" strike="noStrike" spc="-1" dirty="0">
-              <a:latin typeface="Times New Roman"/>
-            </a:endParaRPr>
-          </a:p>
-        </p:txBody>
-      </p:sp>
       <p:pic>
         <p:nvPicPr>
           <p:cNvPr id="4" name="Picture 3" descr="A diagram of a diagram&#10;&#10;AI-generated content may be incorrect.">
@@ -9264,6 +10304,35 @@
           </a:prstGeom>
         </p:spPr>
       </p:pic>
+      <p:sp>
+        <p:nvSpPr>
+          <p:cNvPr id="2" name="Slide Number Placeholder 1">
+            <a:extLst>
+              <a:ext uri="{FF2B5EF4-FFF2-40B4-BE49-F238E27FC236}">
+                <a16:creationId xmlns:a16="http://schemas.microsoft.com/office/drawing/2014/main" id="{48B83348-3B88-161A-684C-ADE785AB2E4E}"/>
+              </a:ext>
+            </a:extLst>
+          </p:cNvPr>
+          <p:cNvSpPr>
+            <a:spLocks noGrp="1"/>
+          </p:cNvSpPr>
+          <p:nvPr>
+            <p:ph type="sldNum" idx="2"/>
+          </p:nvPr>
+        </p:nvSpPr>
+        <p:spPr/>
+        <p:txBody>
+          <a:bodyPr/>
+          <a:lstStyle/>
+          <a:p>
+            <a:fld id="{B99B1A2D-D4B6-4047-AD69-D754256AF902}" type="slidenum">
+              <a:rPr lang="en-MX" smtClean="0"/>
+              <a:t>8</a:t>
+            </a:fld>
+            <a:endParaRPr lang="en-MX"/>
+          </a:p>
+        </p:txBody>
+      </p:sp>
     </p:spTree>
     <p:extLst>
       <p:ext uri="{BB962C8B-B14F-4D97-AF65-F5344CB8AC3E}">
@@ -9277,7 +10346,7 @@
 </p:sld>
 </file>
 
-<file path=ppt/slides/slide8.xml><?xml version="1.0" encoding="utf-8"?>
+<file path=ppt/slides/slide9.xml><?xml version="1.0" encoding="utf-8"?>
 <p:sld xmlns:a="http://schemas.openxmlformats.org/drawingml/2006/main" xmlns:r="http://schemas.openxmlformats.org/officeDocument/2006/relationships" xmlns:p="http://schemas.openxmlformats.org/presentationml/2006/main">
   <p:cSld>
     <p:spTree>
@@ -9342,87 +10411,6 @@
       </p:pic>
       <p:sp>
         <p:nvSpPr>
-          <p:cNvPr id="120" name="PlaceHolder 3"/>
-          <p:cNvSpPr>
-            <a:spLocks noGrp="1"/>
-          </p:cNvSpPr>
-          <p:nvPr>
-            <p:ph type="sldNum" idx="16"/>
-          </p:nvPr>
-        </p:nvSpPr>
-        <p:spPr>
-          <a:xfrm>
-            <a:off x="7227360" y="5165280"/>
-            <a:ext cx="2347920" cy="390240"/>
-          </a:xfrm>
-          <a:prstGeom prst="rect">
-            <a:avLst/>
-          </a:prstGeom>
-          <a:noFill/>
-          <a:ln w="0">
-            <a:noFill/>
-          </a:ln>
-        </p:spPr>
-        <p:txBody>
-          <a:bodyPr lIns="0" tIns="0" rIns="0" bIns="0" anchor="t">
-            <a:noAutofit/>
-          </a:bodyPr>
-          <a:lstStyle>
-            <a:lvl1pPr algn="r">
-              <a:lnSpc>
-                <a:spcPct val="100000"/>
-              </a:lnSpc>
-              <a:buNone/>
-              <a:tabLst>
-                <a:tab pos="0" algn="l"/>
-              </a:tabLst>
-              <a:defRPr lang="es-ES" sz="1400" b="0" strike="noStrike" spc="-1">
-                <a:solidFill>
-                  <a:srgbClr val="000000"/>
-                </a:solidFill>
-                <a:latin typeface="Times New Roman"/>
-                <a:ea typeface="Times New Roman"/>
-              </a:defRPr>
-            </a:lvl1pPr>
-          </a:lstStyle>
-          <a:p>
-            <a:pPr algn="r">
-              <a:lnSpc>
-                <a:spcPct val="100000"/>
-              </a:lnSpc>
-              <a:buNone/>
-              <a:tabLst>
-                <a:tab pos="0" algn="l"/>
-              </a:tabLst>
-            </a:pPr>
-            <a:fld id="{557813AA-4B81-488D-BB56-61607AD110CD}" type="slidenum">
-              <a:rPr lang="es-ES" sz="1400" b="0" strike="noStrike" spc="-1" smtClean="0">
-                <a:solidFill>
-                  <a:srgbClr val="000000"/>
-                </a:solidFill>
-                <a:latin typeface="Times New Roman"/>
-                <a:ea typeface="Times New Roman"/>
-              </a:rPr>
-              <a:t>8</a:t>
-            </a:fld>
-            <a:r>
-              <a:rPr lang="es-ES" sz="1400" b="0" strike="noStrike" spc="-1" dirty="0">
-                <a:solidFill>
-                  <a:srgbClr val="000000"/>
-                </a:solidFill>
-                <a:latin typeface="Times New Roman"/>
-                <a:ea typeface="Times New Roman"/>
-              </a:rPr>
-              <a:t>/16</a:t>
-            </a:r>
-            <a:endParaRPr lang="es-MX" sz="1400" b="0" strike="noStrike" spc="-1" dirty="0">
-              <a:latin typeface="Times New Roman"/>
-            </a:endParaRPr>
-          </a:p>
-        </p:txBody>
-      </p:sp>
-      <p:sp>
-        <p:nvSpPr>
           <p:cNvPr id="2" name="AutoShape 2">
             <a:extLst>
               <a:ext uri="{FF2B5EF4-FFF2-40B4-BE49-F238E27FC236}">
@@ -9502,364 +10490,32 @@
           </a:prstGeom>
         </p:spPr>
       </p:pic>
-    </p:spTree>
-  </p:cSld>
-  <p:clrMapOvr>
-    <a:masterClrMapping/>
-  </p:clrMapOvr>
-</p:sld>
-</file>
-
-<file path=ppt/slides/slide9.xml><?xml version="1.0" encoding="utf-8"?>
-<p:sld xmlns:a="http://schemas.openxmlformats.org/drawingml/2006/main" xmlns:r="http://schemas.openxmlformats.org/officeDocument/2006/relationships" xmlns:p="http://schemas.openxmlformats.org/presentationml/2006/main">
-  <p:cSld>
-    <p:spTree>
-      <p:nvGrpSpPr>
-        <p:cNvPr id="1" name=""/>
-        <p:cNvGrpSpPr/>
-        <p:nvPr/>
-      </p:nvGrpSpPr>
-      <p:grpSpPr>
-        <a:xfrm>
-          <a:off x="0" y="0"/>
-          <a:ext cx="0" cy="0"/>
-          <a:chOff x="0" y="0"/>
-          <a:chExt cx="0" cy="0"/>
-        </a:xfrm>
-      </p:grpSpPr>
-      <p:pic>
-        <p:nvPicPr>
-          <p:cNvPr id="121" name="Google Shape;237;p15"/>
-          <p:cNvPicPr/>
-          <p:nvPr/>
-        </p:nvPicPr>
-        <p:blipFill>
-          <a:blip r:embed="rId2"/>
-          <a:stretch/>
-        </p:blipFill>
-        <p:spPr>
-          <a:xfrm>
-            <a:off x="360" y="4984200"/>
-            <a:ext cx="10079280" cy="685440"/>
-          </a:xfrm>
-          <a:prstGeom prst="rect">
-            <a:avLst/>
-          </a:prstGeom>
-          <a:ln w="0">
-            <a:noFill/>
-          </a:ln>
-        </p:spPr>
-      </p:pic>
-      <p:pic>
-        <p:nvPicPr>
-          <p:cNvPr id="122" name="Google Shape;238;p15"/>
-          <p:cNvPicPr/>
-          <p:nvPr/>
-        </p:nvPicPr>
-        <p:blipFill>
-          <a:blip r:embed="rId3"/>
-          <a:stretch/>
-        </p:blipFill>
-        <p:spPr>
-          <a:xfrm>
-            <a:off x="360" y="0"/>
-            <a:ext cx="1598400" cy="1484280"/>
-          </a:xfrm>
-          <a:prstGeom prst="rect">
-            <a:avLst/>
-          </a:prstGeom>
-          <a:ln w="0">
-            <a:noFill/>
-          </a:ln>
-        </p:spPr>
-      </p:pic>
-      <p:sp>
-        <p:nvSpPr>
-          <p:cNvPr id="123" name="Google Shape;239;p15"/>
-          <p:cNvSpPr/>
-          <p:nvPr/>
-        </p:nvSpPr>
-        <p:spPr>
-          <a:xfrm>
-            <a:off x="922320" y="1915200"/>
-            <a:ext cx="8565480" cy="1919880"/>
-          </a:xfrm>
-          <a:prstGeom prst="rect">
-            <a:avLst/>
-          </a:prstGeom>
-          <a:noFill/>
-          <a:ln w="0">
-            <a:noFill/>
-          </a:ln>
-        </p:spPr>
-        <p:style>
-          <a:lnRef idx="0">
-            <a:scrgbClr r="0" g="0" b="0"/>
-          </a:lnRef>
-          <a:fillRef idx="0">
-            <a:scrgbClr r="0" g="0" b="0"/>
-          </a:fillRef>
-          <a:effectRef idx="0">
-            <a:scrgbClr r="0" g="0" b="0"/>
-          </a:effectRef>
-          <a:fontRef idx="minor"/>
-        </p:style>
-        <p:txBody>
-          <a:bodyPr anchor="t">
-            <a:spAutoFit/>
-          </a:bodyPr>
-          <a:lstStyle/>
-          <a:p>
-            <a:pPr marL="285840" indent="-285840" algn="just">
-              <a:lnSpc>
-                <a:spcPct val="100000"/>
-              </a:lnSpc>
-              <a:buClr>
-                <a:srgbClr val="000000"/>
-              </a:buClr>
-              <a:buFont typeface="Arial"/>
-              <a:buChar char="•"/>
-            </a:pPr>
-            <a:r>
-              <a:rPr lang="es-ES" sz="2400" b="0" strike="noStrike" spc="-1">
-                <a:solidFill>
-                  <a:srgbClr val="000000"/>
-                </a:solidFill>
-                <a:latin typeface="Calibri"/>
-                <a:ea typeface="Calibri"/>
-              </a:rPr>
-              <a:t>Recrear el código de Bullinaria en Python</a:t>
-            </a:r>
-            <a:endParaRPr lang="es-MX" sz="2400" b="0" strike="noStrike" spc="-1">
-              <a:latin typeface="Arial"/>
-            </a:endParaRPr>
-          </a:p>
-          <a:p>
-            <a:pPr algn="just">
-              <a:lnSpc>
-                <a:spcPct val="100000"/>
-              </a:lnSpc>
-              <a:buNone/>
-              <a:tabLst>
-                <a:tab pos="0" algn="l"/>
-              </a:tabLst>
-            </a:pPr>
-            <a:endParaRPr lang="es-MX" sz="2400" b="0" strike="noStrike" spc="-1">
-              <a:latin typeface="Arial"/>
-            </a:endParaRPr>
-          </a:p>
-          <a:p>
-            <a:pPr marL="285840" indent="-285840" algn="just">
-              <a:lnSpc>
-                <a:spcPct val="100000"/>
-              </a:lnSpc>
-              <a:buClr>
-                <a:srgbClr val="000000"/>
-              </a:buClr>
-              <a:buFont typeface="Arial"/>
-              <a:buChar char="•"/>
-              <a:tabLst>
-                <a:tab pos="0" algn="l"/>
-              </a:tabLst>
-            </a:pPr>
-            <a:r>
-              <a:rPr lang="es-ES" sz="2400" b="0" strike="noStrike" spc="-1">
-                <a:solidFill>
-                  <a:srgbClr val="000000"/>
-                </a:solidFill>
-                <a:latin typeface="Calibri"/>
-                <a:ea typeface="Calibri"/>
-              </a:rPr>
-              <a:t>Extender el código con mas de dos matrices de pesos duplicados</a:t>
-            </a:r>
-            <a:endParaRPr lang="es-MX" sz="2400" b="0" strike="noStrike" spc="-1">
-              <a:latin typeface="Arial"/>
-            </a:endParaRPr>
-          </a:p>
-          <a:p>
-            <a:pPr>
-              <a:lnSpc>
-                <a:spcPct val="100000"/>
-              </a:lnSpc>
-              <a:buNone/>
-              <a:tabLst>
-                <a:tab pos="0" algn="l"/>
-              </a:tabLst>
-            </a:pPr>
-            <a:endParaRPr lang="es-MX" sz="2400" b="0" strike="noStrike" spc="-1">
-              <a:latin typeface="Arial"/>
-            </a:endParaRPr>
-          </a:p>
-          <a:p>
-            <a:pPr marL="285840" indent="-285840">
-              <a:lnSpc>
-                <a:spcPct val="100000"/>
-              </a:lnSpc>
-              <a:buClr>
-                <a:srgbClr val="000000"/>
-              </a:buClr>
-              <a:buFont typeface="Arial"/>
-              <a:buChar char="•"/>
-              <a:tabLst>
-                <a:tab pos="0" algn="l"/>
-              </a:tabLst>
-            </a:pPr>
-            <a:r>
-              <a:rPr lang="es-ES" sz="2400" b="0" strike="noStrike" spc="-1">
-                <a:solidFill>
-                  <a:srgbClr val="000000"/>
-                </a:solidFill>
-                <a:latin typeface="Calibri"/>
-                <a:ea typeface="Calibri"/>
-              </a:rPr>
-              <a:t>Realizar una comparación de ambos resultados</a:t>
-            </a:r>
-            <a:endParaRPr lang="es-MX" sz="2400" b="0" strike="noStrike" spc="-1">
-              <a:latin typeface="Arial"/>
-            </a:endParaRPr>
-          </a:p>
-        </p:txBody>
-      </p:sp>
-      <p:sp>
-        <p:nvSpPr>
-          <p:cNvPr id="124" name="Google Shape;240;p15"/>
-          <p:cNvSpPr/>
-          <p:nvPr/>
-        </p:nvSpPr>
-        <p:spPr>
-          <a:xfrm>
-            <a:off x="4031280" y="398160"/>
-            <a:ext cx="2971440" cy="607320"/>
-          </a:xfrm>
-          <a:prstGeom prst="rect">
-            <a:avLst/>
-          </a:prstGeom>
-          <a:noFill/>
-          <a:ln w="0">
-            <a:noFill/>
-          </a:ln>
-        </p:spPr>
-        <p:style>
-          <a:lnRef idx="0">
-            <a:scrgbClr r="0" g="0" b="0"/>
-          </a:lnRef>
-          <a:fillRef idx="0">
-            <a:scrgbClr r="0" g="0" b="0"/>
-          </a:fillRef>
-          <a:effectRef idx="0">
-            <a:scrgbClr r="0" g="0" b="0"/>
-          </a:effectRef>
-          <a:fontRef idx="minor"/>
-        </p:style>
-        <p:txBody>
-          <a:bodyPr anchor="ctr">
-            <a:normAutofit/>
-          </a:bodyPr>
-          <a:lstStyle/>
-          <a:p>
-            <a:pPr algn="ctr">
-              <a:lnSpc>
-                <a:spcPct val="100000"/>
-              </a:lnSpc>
-              <a:buNone/>
-              <a:tabLst>
-                <a:tab pos="0" algn="l"/>
-              </a:tabLst>
-            </a:pPr>
-            <a:r>
-              <a:rPr lang="es-ES" sz="2600" b="1" strike="noStrike" spc="-1">
-                <a:solidFill>
-                  <a:srgbClr val="000000"/>
-                </a:solidFill>
-                <a:latin typeface="Calibri"/>
-                <a:ea typeface="Calibri"/>
-              </a:rPr>
-              <a:t>Metodología </a:t>
-            </a:r>
-            <a:endParaRPr lang="es-MX" sz="2600" b="0" strike="noStrike" spc="-1">
-              <a:latin typeface="Arial"/>
-            </a:endParaRPr>
-          </a:p>
-        </p:txBody>
-      </p:sp>
-      <p:sp>
-        <p:nvSpPr>
-          <p:cNvPr id="125" name="PlaceHolder 1"/>
+      <p:sp>
+        <p:nvSpPr>
+          <p:cNvPr id="3" name="Slide Number Placeholder 2">
+            <a:extLst>
+              <a:ext uri="{FF2B5EF4-FFF2-40B4-BE49-F238E27FC236}">
+                <a16:creationId xmlns:a16="http://schemas.microsoft.com/office/drawing/2014/main" id="{A86105B2-1EB6-E593-FEFB-EA1D394F4049}"/>
+              </a:ext>
+            </a:extLst>
+          </p:cNvPr>
           <p:cNvSpPr>
             <a:spLocks noGrp="1"/>
           </p:cNvSpPr>
           <p:nvPr>
-            <p:ph type="sldNum" idx="17"/>
+            <p:ph type="sldNum" idx="2"/>
           </p:nvPr>
         </p:nvSpPr>
-        <p:spPr>
-          <a:xfrm>
-            <a:off x="7227360" y="5165280"/>
-            <a:ext cx="2347920" cy="390240"/>
-          </a:xfrm>
-          <a:prstGeom prst="rect">
-            <a:avLst/>
-          </a:prstGeom>
-          <a:noFill/>
-          <a:ln w="0">
-            <a:noFill/>
-          </a:ln>
-        </p:spPr>
-        <p:txBody>
-          <a:bodyPr lIns="0" tIns="0" rIns="0" bIns="0" anchor="t">
-            <a:noAutofit/>
-          </a:bodyPr>
-          <a:lstStyle>
-            <a:lvl1pPr algn="r">
-              <a:lnSpc>
-                <a:spcPct val="100000"/>
-              </a:lnSpc>
-              <a:buNone/>
-              <a:tabLst>
-                <a:tab pos="0" algn="l"/>
-              </a:tabLst>
-              <a:defRPr lang="es-ES" sz="1400" b="0" strike="noStrike" spc="-1">
-                <a:solidFill>
-                  <a:srgbClr val="000000"/>
-                </a:solidFill>
-                <a:latin typeface="Times New Roman"/>
-                <a:ea typeface="Times New Roman"/>
-              </a:defRPr>
-            </a:lvl1pPr>
-          </a:lstStyle>
-          <a:p>
-            <a:pPr algn="r">
-              <a:lnSpc>
-                <a:spcPct val="100000"/>
-              </a:lnSpc>
-              <a:buNone/>
-              <a:tabLst>
-                <a:tab pos="0" algn="l"/>
-              </a:tabLst>
-            </a:pPr>
-            <a:fld id="{EAAF4C53-206A-432B-85F3-585E33D2ACC4}" type="slidenum">
-              <a:rPr lang="es-ES" sz="1400" b="0" strike="noStrike" spc="-1" smtClean="0">
-                <a:solidFill>
-                  <a:srgbClr val="000000"/>
-                </a:solidFill>
-                <a:latin typeface="Times New Roman"/>
-                <a:ea typeface="Times New Roman"/>
-              </a:rPr>
+        <p:spPr/>
+        <p:txBody>
+          <a:bodyPr/>
+          <a:lstStyle/>
+          <a:p>
+            <a:fld id="{B99B1A2D-D4B6-4047-AD69-D754256AF902}" type="slidenum">
+              <a:rPr lang="en-MX" smtClean="0"/>
               <a:t>9</a:t>
             </a:fld>
-            <a:r>
-              <a:rPr lang="es-ES" sz="1400" b="0" strike="noStrike" spc="-1" dirty="0">
-                <a:solidFill>
-                  <a:srgbClr val="000000"/>
-                </a:solidFill>
-                <a:latin typeface="Times New Roman"/>
-                <a:ea typeface="Times New Roman"/>
-              </a:rPr>
-              <a:t>/16</a:t>
-            </a:r>
-            <a:endParaRPr lang="es-MX" sz="1400" b="0" strike="noStrike" spc="-1" dirty="0">
-              <a:latin typeface="Times New Roman"/>
-            </a:endParaRPr>
+            <a:endParaRPr lang="en-MX"/>
           </a:p>
         </p:txBody>
       </p:sp>

</xml_diff>